<commit_message>
Add security review route and benchmark wiring
</commit_message>
<xml_diff>
--- a/deck/cardano-risk-analyst.pptx
+++ b/deck/cardano-risk-analyst.pptx
@@ -13,6 +13,7 @@
     <p:sldId id="261" r:id="rId12"/>
     <p:sldId id="262" r:id="rId13"/>
     <p:sldId id="263" r:id="rId14"/>
+    <p:sldId id="264" r:id="rId15"/>
   </p:sldIdLst>
   <p:sldSz cx="12188952" cy="6858000" type="screen4x3"/>
   <p:notesSz cx="6858000" cy="9144000"/>
@@ -6027,7 +6028,7 @@
               </a:defRPr>
             </a:pPr>
             <a:r>
-              <a:t>Run the CLI, open the report, or hire the Coworker.</a:t>
+              <a:t>Run the CLI, open the report, or hire either Coworker.</a:t>
             </a:r>
           </a:p>
         </p:txBody>
@@ -6163,7 +6164,7 @@
               </a:defRPr>
             </a:pPr>
             <a:r>
-              <a:t>Follow the payment</a:t>
+              <a:t>Security gate</a:t>
             </a:r>
           </a:p>
           <a:p>
@@ -6176,19 +6177,19 @@
               </a:defRPr>
             </a:pPr>
             <a:r>
-              <a:t>Sokosumi Task</a:t>
+              <a:t>Aiken Security Reviewer</a:t>
             </a:r>
             <a:br/>
             <a:r>
-              <a:t>→ MPS status</a:t>
+              <a:t>agent-to-agent Masumi hire</a:t>
             </a:r>
             <a:br/>
             <a:r>
-              <a:t>→ memo result</a:t>
+              <a:t>exploit test must pass</a:t>
             </a:r>
             <a:br/>
             <a:r>
-              <a:t>→ seller-wallet settlement</a:t>
+              <a:t>benchmark: known / confirmed / cap</a:t>
             </a:r>
           </a:p>
         </p:txBody>
@@ -6196,6 +6197,465 @@
       <p:sp>
         <p:nvSpPr>
           <p:cNvPr id="8" name="TextBox 7"/>
+          <p:cNvSpPr txBox="1"/>
+          <p:nvPr/>
+        </p:nvSpPr>
+        <p:spPr>
+          <a:xfrm>
+            <a:off x="640080" y="6355080"/>
+            <a:ext cx="8686800" cy="228600"/>
+          </a:xfrm>
+          <a:prstGeom prst="rect">
+            <a:avLst/>
+          </a:prstGeom>
+          <a:noFill/>
+        </p:spPr>
+        <p:txBody>
+          <a:bodyPr wrap="square">
+            <a:spAutoFit/>
+          </a:bodyPr>
+          <a:lstStyle/>
+          <a:p>
+            <a:pPr algn="l">
+              <a:defRPr sz="1100" b="0">
+                <a:solidFill>
+                  <a:srgbClr val="5B6B73"/>
+                </a:solidFill>
+                <a:latin typeface="Aptos"/>
+              </a:defRPr>
+            </a:pPr>
+            <a:r>
+              <a:t>Cardano Risk Analyst | Sokosumi + Masumi</a:t>
+            </a:r>
+          </a:p>
+        </p:txBody>
+      </p:sp>
+    </p:spTree>
+  </p:cSld>
+  <p:clrMapOvr>
+    <a:masterClrMapping/>
+  </p:clrMapOvr>
+</p:sld>
+</file>
+
+<file path=ppt/slides/slide9.xml><?xml version="1.0" encoding="utf-8"?>
+<p:sld xmlns:a="http://schemas.openxmlformats.org/drawingml/2006/main" xmlns:p="http://schemas.openxmlformats.org/presentationml/2006/main" xmlns:r="http://schemas.openxmlformats.org/officeDocument/2006/relationships">
+  <p:cSld>
+    <p:bg>
+      <p:bgPr>
+        <a:solidFill>
+          <a:srgbClr val="F4F7F5"/>
+        </a:solidFill>
+        <a:effectLst/>
+      </p:bgPr>
+    </p:bg>
+    <p:spTree>
+      <p:nvGrpSpPr>
+        <p:cNvPr id="1" name=""/>
+        <p:cNvGrpSpPr/>
+        <p:nvPr/>
+      </p:nvGrpSpPr>
+      <p:grpSpPr/>
+      <p:sp>
+        <p:nvSpPr>
+          <p:cNvPr id="2" name="TextBox 1"/>
+          <p:cNvSpPr txBox="1"/>
+          <p:nvPr/>
+        </p:nvSpPr>
+        <p:spPr>
+          <a:xfrm>
+            <a:off x="640080" y="365760"/>
+            <a:ext cx="10607040" cy="594360"/>
+          </a:xfrm>
+          <a:prstGeom prst="rect">
+            <a:avLst/>
+          </a:prstGeom>
+          <a:noFill/>
+        </p:spPr>
+        <p:txBody>
+          <a:bodyPr wrap="square">
+            <a:spAutoFit/>
+          </a:bodyPr>
+          <a:lstStyle/>
+          <a:p>
+            <a:pPr algn="l">
+              <a:defRPr sz="3800" b="1">
+                <a:solidFill>
+                  <a:srgbClr val="13252F"/>
+                </a:solidFill>
+                <a:latin typeface="Trebuchet MS"/>
+              </a:defRPr>
+            </a:pPr>
+            <a:r>
+              <a:t>Live verdicts and holder evidence</a:t>
+            </a:r>
+          </a:p>
+        </p:txBody>
+      </p:sp>
+      <p:sp>
+        <p:nvSpPr>
+          <p:cNvPr id="3" name="Rectangle 2"/>
+          <p:cNvSpPr/>
+          <p:nvPr/>
+        </p:nvSpPr>
+        <p:spPr>
+          <a:xfrm>
+            <a:off x="640080" y="1143000"/>
+            <a:ext cx="914400" cy="73152"/>
+          </a:xfrm>
+          <a:prstGeom prst="rect">
+            <a:avLst/>
+          </a:prstGeom>
+          <a:solidFill>
+            <a:srgbClr val="00786B"/>
+          </a:solidFill>
+          <a:ln>
+            <a:noFill/>
+          </a:ln>
+        </p:spPr>
+        <p:style>
+          <a:lnRef idx="1">
+            <a:schemeClr val="accent1"/>
+          </a:lnRef>
+          <a:fillRef idx="3">
+            <a:schemeClr val="accent1"/>
+          </a:fillRef>
+          <a:effectRef idx="2">
+            <a:schemeClr val="accent1"/>
+          </a:effectRef>
+          <a:fontRef idx="minor">
+            <a:schemeClr val="lt1"/>
+          </a:fontRef>
+        </p:style>
+        <p:txBody>
+          <a:bodyPr rtlCol="0" anchor="ctr"/>
+          <a:lstStyle/>
+          <a:p>
+            <a:pPr algn="ctr"/>
+          </a:p>
+        </p:txBody>
+      </p:sp>
+      <p:sp>
+        <p:nvSpPr>
+          <p:cNvPr id="4" name="TextBox 3"/>
+          <p:cNvSpPr txBox="1"/>
+          <p:nvPr/>
+        </p:nvSpPr>
+        <p:spPr>
+          <a:xfrm>
+            <a:off x="10881360" y="6355080"/>
+            <a:ext cx="640080" cy="228600"/>
+          </a:xfrm>
+          <a:prstGeom prst="rect">
+            <a:avLst/>
+          </a:prstGeom>
+          <a:noFill/>
+        </p:spPr>
+        <p:txBody>
+          <a:bodyPr wrap="square">
+            <a:spAutoFit/>
+          </a:bodyPr>
+          <a:lstStyle/>
+          <a:p>
+            <a:pPr algn="r">
+              <a:defRPr sz="1100" b="0">
+                <a:solidFill>
+                  <a:srgbClr val="5B6B73"/>
+                </a:solidFill>
+                <a:latin typeface="Aptos"/>
+              </a:defRPr>
+            </a:pPr>
+            <a:r>
+              <a:t>9/8</a:t>
+            </a:r>
+          </a:p>
+        </p:txBody>
+      </p:sp>
+      <p:sp>
+        <p:nvSpPr>
+          <p:cNvPr id="5" name="Rounded Rectangle 4"/>
+          <p:cNvSpPr/>
+          <p:nvPr/>
+        </p:nvSpPr>
+        <p:spPr>
+          <a:xfrm>
+            <a:off x="640080" y="1645920"/>
+            <a:ext cx="3429000" cy="2560320"/>
+          </a:xfrm>
+          <a:prstGeom prst="roundRect">
+            <a:avLst>
+              <a:gd name="adj" fmla="val 8000"/>
+            </a:avLst>
+          </a:prstGeom>
+          <a:solidFill>
+            <a:srgbClr val="FFFFFF"/>
+          </a:solidFill>
+          <a:ln w="19050">
+            <a:solidFill>
+              <a:srgbClr val="00786B"/>
+            </a:solidFill>
+          </a:ln>
+        </p:spPr>
+        <p:style>
+          <a:lnRef idx="1">
+            <a:schemeClr val="accent1"/>
+          </a:lnRef>
+          <a:fillRef idx="3">
+            <a:schemeClr val="accent1"/>
+          </a:fillRef>
+          <a:effectRef idx="2">
+            <a:schemeClr val="accent1"/>
+          </a:effectRef>
+          <a:fontRef idx="minor">
+            <a:schemeClr val="lt1"/>
+          </a:fontRef>
+        </p:style>
+        <p:txBody>
+          <a:bodyPr rtlCol="0" anchor="ctr" wrap="square"/>
+          <a:lstStyle/>
+          <a:p>
+            <a:pPr algn="ctr">
+              <a:defRPr sz="1800" b="1">
+                <a:solidFill>
+                  <a:srgbClr val="00786B"/>
+                </a:solidFill>
+                <a:latin typeface="Trebuchet MS"/>
+              </a:defRPr>
+            </a:pPr>
+            <a:r>
+              <a:t>MIN · HIGH</a:t>
+            </a:r>
+          </a:p>
+          <a:p>
+            <a:pPr>
+              <a:defRPr sz="1400">
+                <a:solidFill>
+                  <a:srgbClr val="13252F"/>
+                </a:solidFill>
+                <a:latin typeface="Aptos"/>
+              </a:defRPr>
+            </a:pPr>
+            <a:r>
+              <a:t>Native mint policy</a:t>
+            </a:r>
+            <a:br/>
+            <a:r>
+              <a:t>1 required signer</a:t>
+            </a:r>
+            <a:br/>
+            <a:r>
+              <a:t>No time lock</a:t>
+            </a:r>
+            <a:br/>
+            <a:r>
+              <a:t>Blockfrost top-100 sample flagged</a:t>
+            </a:r>
+          </a:p>
+        </p:txBody>
+      </p:sp>
+      <p:sp>
+        <p:nvSpPr>
+          <p:cNvPr id="6" name="Rounded Rectangle 5"/>
+          <p:cNvSpPr/>
+          <p:nvPr/>
+        </p:nvSpPr>
+        <p:spPr>
+          <a:xfrm>
+            <a:off x="4389120" y="1645920"/>
+            <a:ext cx="3429000" cy="2560320"/>
+          </a:xfrm>
+          <a:prstGeom prst="roundRect">
+            <a:avLst>
+              <a:gd name="adj" fmla="val 8000"/>
+            </a:avLst>
+          </a:prstGeom>
+          <a:solidFill>
+            <a:srgbClr val="FFFFFF"/>
+          </a:solidFill>
+          <a:ln w="19050">
+            <a:solidFill>
+              <a:srgbClr val="D9E2E0"/>
+            </a:solidFill>
+          </a:ln>
+        </p:spPr>
+        <p:style>
+          <a:lnRef idx="1">
+            <a:schemeClr val="accent1"/>
+          </a:lnRef>
+          <a:fillRef idx="3">
+            <a:schemeClr val="accent1"/>
+          </a:fillRef>
+          <a:effectRef idx="2">
+            <a:schemeClr val="accent1"/>
+          </a:effectRef>
+          <a:fontRef idx="minor">
+            <a:schemeClr val="lt1"/>
+          </a:fontRef>
+        </p:style>
+        <p:txBody>
+          <a:bodyPr rtlCol="0" anchor="ctr" wrap="square"/>
+          <a:lstStyle/>
+          <a:p>
+            <a:pPr algn="ctr">
+              <a:defRPr sz="1800" b="1">
+                <a:solidFill>
+                  <a:srgbClr val="13252F"/>
+                </a:solidFill>
+                <a:latin typeface="Trebuchet MS"/>
+              </a:defRPr>
+            </a:pPr>
+            <a:r>
+              <a:t>SNEK · LOW</a:t>
+            </a:r>
+          </a:p>
+          <a:p>
+            <a:pPr>
+              <a:defRPr sz="1400">
+                <a:solidFill>
+                  <a:srgbClr val="13252F"/>
+                </a:solidFill>
+                <a:latin typeface="Aptos"/>
+              </a:defRPr>
+            </a:pPr>
+            <a:r>
+              <a:t>Timelocked native policy</a:t>
+            </a:r>
+            <a:br/>
+            <a:r>
+              <a:t>999 holders</a:t>
+            </a:r>
+            <a:br/>
+            <a:r>
+              <a:t>Top 1: 4.08%</a:t>
+            </a:r>
+            <a:br/>
+            <a:r>
+              <a:t>Top 10: 20.80%</a:t>
+            </a:r>
+          </a:p>
+        </p:txBody>
+      </p:sp>
+      <p:sp>
+        <p:nvSpPr>
+          <p:cNvPr id="7" name="Rounded Rectangle 6"/>
+          <p:cNvSpPr/>
+          <p:nvPr/>
+        </p:nvSpPr>
+        <p:spPr>
+          <a:xfrm>
+            <a:off x="8138160" y="1645920"/>
+            <a:ext cx="3429000" cy="2560320"/>
+          </a:xfrm>
+          <a:prstGeom prst="roundRect">
+            <a:avLst>
+              <a:gd name="adj" fmla="val 8000"/>
+            </a:avLst>
+          </a:prstGeom>
+          <a:solidFill>
+            <a:srgbClr val="FFFFFF"/>
+          </a:solidFill>
+          <a:ln w="19050">
+            <a:solidFill>
+              <a:srgbClr val="D9E2E0"/>
+            </a:solidFill>
+          </a:ln>
+        </p:spPr>
+        <p:style>
+          <a:lnRef idx="1">
+            <a:schemeClr val="accent1"/>
+          </a:lnRef>
+          <a:fillRef idx="3">
+            <a:schemeClr val="accent1"/>
+          </a:fillRef>
+          <a:effectRef idx="2">
+            <a:schemeClr val="accent1"/>
+          </a:effectRef>
+          <a:fontRef idx="minor">
+            <a:schemeClr val="lt1"/>
+          </a:fontRef>
+        </p:style>
+        <p:txBody>
+          <a:bodyPr rtlCol="0" anchor="ctr" wrap="square"/>
+          <a:lstStyle/>
+          <a:p>
+            <a:pPr algn="ctr">
+              <a:defRPr sz="1800" b="1">
+                <a:solidFill>
+                  <a:srgbClr val="13252F"/>
+                </a:solidFill>
+                <a:latin typeface="Trebuchet MS"/>
+              </a:defRPr>
+            </a:pPr>
+            <a:r>
+              <a:t>Benchmark</a:t>
+            </a:r>
+          </a:p>
+          <a:p>
+            <a:pPr>
+              <a:defRPr sz="1400">
+                <a:solidFill>
+                  <a:srgbClr val="13252F"/>
+                </a:solidFill>
+                <a:latin typeface="Aptos"/>
+              </a:defRPr>
+            </a:pPr>
+            <a:r>
+              <a:t>ce28fef + fixed 6a45d0a</a:t>
+            </a:r>
+            <a:br/>
+            <a:r>
+              <a:t>01_sell_nft</a:t>
+            </a:r>
+            <a:br/>
+            <a:r>
+              <a:t>bank_01_deposit_vulnerability</a:t>
+            </a:r>
+            <a:br/>
+            <a:r>
+              <a:t>Passing exploit tests only</a:t>
+            </a:r>
+          </a:p>
+        </p:txBody>
+      </p:sp>
+      <p:sp>
+        <p:nvSpPr>
+          <p:cNvPr id="8" name="TextBox 7"/>
+          <p:cNvSpPr txBox="1"/>
+          <p:nvPr/>
+        </p:nvSpPr>
+        <p:spPr>
+          <a:xfrm>
+            <a:off x="640080" y="4892040"/>
+            <a:ext cx="10881360" cy="594360"/>
+          </a:xfrm>
+          <a:prstGeom prst="rect">
+            <a:avLst/>
+          </a:prstGeom>
+          <a:noFill/>
+        </p:spPr>
+        <p:txBody>
+          <a:bodyPr wrap="square">
+            <a:spAutoFit/>
+          </a:bodyPr>
+          <a:lstStyle/>
+          <a:p>
+            <a:pPr algn="ctr">
+              <a:defRPr sz="1800" b="1">
+                <a:solidFill>
+                  <a:srgbClr val="13252F"/>
+                </a:solidFill>
+                <a:latin typeface="Aptos"/>
+              </a:defRPr>
+            </a:pPr>
+            <a:r>
+              <a:t>The Risk Analyst hires the Aiken Security Reviewer through Masumi escrow when a public script needs an exploit-gated review.</a:t>
+            </a:r>
+          </a:p>
+        </p:txBody>
+      </p:sp>
+      <p:sp>
+        <p:nvSpPr>
+          <p:cNvPr id="9" name="TextBox 8"/>
           <p:cNvSpPr txBox="1"/>
           <p:nvPr/>
         </p:nvSpPr>

</xml_diff>

<commit_message>
Align public risk evidence and security flow
</commit_message>
<xml_diff>
--- a/deck/cardano-risk-analyst.pptx
+++ b/deck/cardano-risk-analyst.pptx
@@ -5675,7 +5675,11 @@
               </a:defRPr>
             </a:pPr>
             <a:r>
-              <a:t>Choose Cardano Risk Analyst on Sokosumi</a:t>
+              <a:t>Choose Cardano Risk Analyst</a:t>
+            </a:r>
+            <a:br/>
+            <a:r>
+              <a:t>Coworker: 01a11080-a6c3-7686-abf4-b0d1594cb82b</a:t>
             </a:r>
           </a:p>
         </p:txBody>
@@ -6185,11 +6189,11 @@
             </a:r>
             <a:br/>
             <a:r>
+              <a:t>live scan produces candidates</a:t>
+            </a:r>
+            <a:br/>
+            <a:r>
               <a:t>exploit test must pass</a:t>
-            </a:r>
-            <a:br/>
-            <a:r>
-              <a:t>benchmark: known / confirmed / cap</a:t>
             </a:r>
           </a:p>
         </p:txBody>
@@ -6522,15 +6526,15 @@
             </a:r>
             <a:br/>
             <a:r>
-              <a:t>999 holders</a:t>
+              <a:t>Largest 88 holder addresses sampled</a:t>
             </a:r>
             <a:br/>
             <a:r>
-              <a:t>Top 1: 4.08%</a:t>
+              <a:t>Top 1: 2.39%</a:t>
             </a:r>
             <a:br/>
             <a:r>
-              <a:t>Top 10: 20.80%</a:t>
+              <a:t>Top 10: 6.57%</a:t>
             </a:r>
           </a:p>
         </p:txBody>
@@ -6587,7 +6591,7 @@
               </a:defRPr>
             </a:pPr>
             <a:r>
-              <a:t>Benchmark</a:t>
+              <a:t>Live scanner</a:t>
             </a:r>
           </a:p>
           <a:p>
@@ -6600,19 +6604,19 @@
               </a:defRPr>
             </a:pPr>
             <a:r>
-              <a:t>ce28fef + fixed 6a45d0a</a:t>
+              <a:t>Aiken source</a:t>
             </a:r>
             <a:br/>
             <a:r>
-              <a:t>01_sell_nft</a:t>
+              <a:t>Candidates and attack tests</a:t>
             </a:r>
             <a:br/>
             <a:r>
-              <a:t>bank_01_deposit_vulnerability</a:t>
+              <a:t>Passing exploit tests only</a:t>
             </a:r>
             <a:br/>
             <a:r>
-              <a:t>Passing exploit tests only</a:t>
+              <a:t>Rule + file + line evidence</a:t>
             </a:r>
           </a:p>
         </p:txBody>

</xml_diff>

<commit_message>
reframe analyst around contract interaction verdict
</commit_message>
<xml_diff>
--- a/deck/cardano-risk-analyst.pptx
+++ b/deck/cardano-risk-analyst.pptx
@@ -3135,7 +3135,7 @@
               </a:defRPr>
             </a:pPr>
             <a:r>
-              <a:t>Before you swap into a Cardano token,</a:t>
+              <a:t>Should I interact with this</a:t>
             </a:r>
           </a:p>
         </p:txBody>
@@ -3171,7 +3171,7 @@
               </a:defRPr>
             </a:pPr>
             <a:r>
-              <a:t>hire an analyst that reads the chain.</a:t>
+              <a:t>Cardano contract?</a:t>
             </a:r>
           </a:p>
         </p:txBody>
@@ -3207,7 +3207,7 @@
               </a:defRPr>
             </a:pPr>
             <a:r>
-              <a:t>A paid Coworker that turns policy, holders, liquidity, and activity into a cited verdict.</a:t>
+              <a:t>One paid Coworker for control, code safety, and getting in and out.</a:t>
             </a:r>
           </a:p>
         </p:txBody>
@@ -3420,7 +3420,7 @@
               </a:defRPr>
             </a:pPr>
             <a:r>
-              <a:t>Token names are easy to copy. Control and exit conditions are not.</a:t>
+              <a:t>Tokens, pools, lending markets, escrows, and Plutus scripts use the same decision.</a:t>
             </a:r>
           </a:p>
         </p:txBody>
@@ -3477,7 +3477,7 @@
               </a:defRPr>
             </a:pPr>
             <a:r>
-              <a:t>Identity</a:t>
+              <a:t>Who controls it</a:t>
             </a:r>
           </a:p>
           <a:p>
@@ -3490,7 +3490,7 @@
               </a:defRPr>
             </a:pPr>
             <a:r>
-              <a:t>Registry name, ticker, decimals, URL, policy unit</a:t>
+              <a:t>Policy, admin key, age, protocol identity, holders</a:t>
             </a:r>
           </a:p>
         </p:txBody>
@@ -3547,7 +3547,7 @@
               </a:defRPr>
             </a:pPr>
             <a:r>
-              <a:t>Control</a:t>
+              <a:t>Is the code safe</a:t>
             </a:r>
           </a:p>
           <a:p>
@@ -3560,7 +3560,7 @@
               </a:defRPr>
             </a:pPr>
             <a:r>
-              <a:t>Mint policy type, timelock, signers, mint status</a:t>
+              <a:t>Script type, size, source review when public</a:t>
             </a:r>
           </a:p>
         </p:txBody>
@@ -3617,7 +3617,7 @@
               </a:defRPr>
             </a:pPr>
             <a:r>
-              <a:t>Exit</a:t>
+              <a:t>Can you get in and out</a:t>
             </a:r>
           </a:p>
           <a:p>
@@ -3630,7 +3630,7 @@
               </a:defRPr>
             </a:pPr>
             <a:r>
-              <a:t>Holder concentration, DEX liquidity, recent activity</a:t>
+              <a:t>TVL, UTxOs, transactions, liquidity, Settlement Desk</a:t>
             </a:r>
           </a:p>
         </p:txBody>
@@ -3913,7 +3913,7 @@
               </a:defRPr>
             </a:pPr>
             <a:r>
-              <a:t>ticker, fingerprint, or unit</a:t>
+              <a:t>token, address, hash, or repo</a:t>
             </a:r>
           </a:p>
         </p:txBody>
@@ -3983,7 +3983,7 @@
               </a:defRPr>
             </a:pPr>
             <a:r>
-              <a:t>Koios, Minswap, registry</a:t>
+              <a:t>Koios, protocol data, registry</a:t>
             </a:r>
           </a:p>
         </p:txBody>
@@ -4053,7 +4053,7 @@
               </a:defRPr>
             </a:pPr>
             <a:r>
-              <a:t>high, medium, low findings</a:t>
+              <a:t>interaction findings</a:t>
             </a:r>
           </a:p>
         </p:txBody>
@@ -4814,7 +4814,7 @@
               </a:defRPr>
             </a:pPr>
             <a:r>
-              <a:t>LOW</a:t>
+              <a:t>INTERACT</a:t>
             </a:r>
           </a:p>
           <a:p>
@@ -4827,7 +4827,7 @@
               </a:defRPr>
             </a:pPr>
             <a:r>
-              <a:t>No high finding and fewer than two medium findings. Read the memo before acting.</a:t>
+              <a:t>No high finding and fewer than two medium findings.</a:t>
             </a:r>
           </a:p>
         </p:txBody>
@@ -4884,7 +4884,7 @@
               </a:defRPr>
             </a:pPr>
             <a:r>
-              <a:t>MEDIUM</a:t>
+              <a:t>INTERACT WITH CONDITIONS</a:t>
             </a:r>
           </a:p>
           <a:p>
@@ -4897,7 +4897,7 @@
               </a:defRPr>
             </a:pPr>
             <a:r>
-              <a:t>At least two medium findings. Investigate concentration, liquidity, age, or registry identity.</a:t>
+              <a:t>Medium findings need a buyer decision before signing.</a:t>
             </a:r>
           </a:p>
         </p:txBody>
@@ -4954,7 +4954,7 @@
               </a:defRPr>
             </a:pPr>
             <a:r>
-              <a:t>HIGH</a:t>
+              <a:t>DO NOT INTERACT</a:t>
             </a:r>
           </a:p>
           <a:p>
@@ -4967,7 +4967,7 @@
               </a:defRPr>
             </a:pPr>
             <a:r>
-              <a:t>A high finding is present, such as open minting, concentrated ownership, or recent minting.</a:t>
+              <a:t>A high finding is present, such as a single admin key.</a:t>
             </a:r>
           </a:p>
         </p:txBody>

</xml_diff>

<commit_message>
pptx: approval-step title and the real two-seller run with the production call
</commit_message>
<xml_diff>
--- a/deck/cardano-risk-analyst.pptx
+++ b/deck/cardano-risk-analyst.pptx
@@ -3137,7 +3137,7 @@
               </a:defRPr>
             </a:pPr>
             <a:r>
-              <a:t>Should my agent pay this</a:t>
+              <a:t>An approval step before your agent</a:t>
             </a:r>
           </a:p>
         </p:txBody>
@@ -3173,7 +3173,7 @@
               </a:defRPr>
             </a:pPr>
             <a:r>
-              <a:t>Cardano counterparty?</a:t>
+              <a:t>pays anyone on Cardano.</a:t>
             </a:r>
           </a:p>
         </p:txBody>
@@ -3343,7 +3343,7 @@
               </a:defRPr>
             </a:pPr>
             <a:r>
-              <a:t>The agent demo has one safe branch</a:t>
+              <a:t>One agent paid one seller and refused the other</a:t>
             </a:r>
           </a:p>
         </p:txBody>
@@ -3450,7 +3450,7 @@
           <a:lstStyle/>
           <a:p>
             <a:pPr algn="l">
-              <a:defRPr sz="2300" b="0">
+              <a:defRPr sz="2100" b="0">
                 <a:solidFill>
                   <a:srgbClr val="1F242E"/>
                 </a:solidFill>
@@ -3458,7 +3458,7 @@
               </a:defRPr>
             </a:pPr>
             <a:r>
-              <a:t>The execution agent pays a seller only when the assessment is not DO_NOT_INTERACT.</a:t>
+              <a:t>Before paying either seller, the agent paid the Risk Desk 1 ADA over x402 and acted on the verdict.</a:t>
             </a:r>
           </a:p>
         </p:txBody>
@@ -3472,7 +3472,87 @@
         <p:spPr>
           <a:xfrm>
             <a:off x="640080" y="2240280"/>
-            <a:ext cx="3429000" cy="2377440"/>
+            <a:ext cx="3429000" cy="2651760"/>
+          </a:xfrm>
+          <a:prstGeom prst="rect">
+            <a:avLst/>
+          </a:prstGeom>
+          <a:solidFill>
+            <a:srgbClr val="F8F9FB"/>
+          </a:solidFill>
+          <a:ln w="15240">
+            <a:solidFill>
+              <a:srgbClr val="4678E8"/>
+            </a:solidFill>
+          </a:ln>
+        </p:spPr>
+        <p:style>
+          <a:lnRef idx="1">
+            <a:schemeClr val="accent1"/>
+          </a:lnRef>
+          <a:fillRef idx="3">
+            <a:schemeClr val="accent1"/>
+          </a:fillRef>
+          <a:effectRef idx="2">
+            <a:schemeClr val="accent1"/>
+          </a:effectRef>
+          <a:fontRef idx="minor">
+            <a:schemeClr val="lt1"/>
+          </a:fontRef>
+        </p:style>
+        <p:txBody>
+          <a:bodyPr rtlCol="0" anchor="ctr" wrap="square"/>
+          <a:lstStyle/>
+          <a:p>
+            <a:pPr algn="ctr">
+              <a:defRPr sz="1700" b="1">
+                <a:solidFill>
+                  <a:srgbClr val="4678E8"/>
+                </a:solidFill>
+                <a:latin typeface="Space Grotesk"/>
+              </a:defRPr>
+            </a:pPr>
+            <a:r>
+              <a:t>Seller A  /  INTERACT</a:t>
+            </a:r>
+          </a:p>
+          <a:p>
+            <a:pPr>
+              <a:defRPr sz="1300">
+                <a:solidFill>
+                  <a:srgbClr val="1F242E"/>
+                </a:solidFill>
+                <a:latin typeface="Arial"/>
+              </a:defRPr>
+            </a:pPr>
+            <a:r>
+              <a:t>Asks 2 ADA</a:t>
+            </a:r>
+            <a:br/>
+            <a:r>
+              <a:t>Wallet: 27 txs since 5 Oct</a:t>
+            </a:r>
+            <a:br/>
+            <a:r>
+              <a:t>Risk check fc053ce1...</a:t>
+            </a:r>
+            <a:br/>
+            <a:r>
+              <a:t>Paid 3866ed31...</a:t>
+            </a:r>
+          </a:p>
+        </p:txBody>
+      </p:sp>
+      <p:sp>
+        <p:nvSpPr>
+          <p:cNvPr id="7" name="Rectangle 6"/>
+          <p:cNvSpPr/>
+          <p:nvPr/>
+        </p:nvSpPr>
+        <p:spPr>
+          <a:xfrm>
+            <a:off x="4389120" y="2240280"/>
+            <a:ext cx="3429000" cy="2651760"/>
           </a:xfrm>
           <a:prstGeom prst="rect">
             <a:avLst/>
@@ -3513,7 +3593,7 @@
               </a:defRPr>
             </a:pPr>
             <a:r>
-              <a:t>Seller returns 402</a:t>
+              <a:t>Seller B  /  DO NOT INTERACT</a:t>
             </a:r>
           </a:p>
           <a:p>
@@ -3526,75 +3606,19 @@
               </a:defRPr>
             </a:pPr>
             <a:r>
-              <a:t>The agent reads the payment requirements and target.</a:t>
-            </a:r>
-          </a:p>
-        </p:txBody>
-      </p:sp>
-      <p:sp>
-        <p:nvSpPr>
-          <p:cNvPr id="7" name="Rectangle 6"/>
-          <p:cNvSpPr/>
-          <p:nvPr/>
-        </p:nvSpPr>
-        <p:spPr>
-          <a:xfrm>
-            <a:off x="4389120" y="2240280"/>
-            <a:ext cx="3429000" cy="2377440"/>
-          </a:xfrm>
-          <a:prstGeom prst="rect">
-            <a:avLst/>
-          </a:prstGeom>
-          <a:solidFill>
-            <a:srgbClr val="F8F9FB"/>
-          </a:solidFill>
-          <a:ln w="15240">
-            <a:solidFill>
-              <a:srgbClr val="4678E8"/>
-            </a:solidFill>
-          </a:ln>
-        </p:spPr>
-        <p:style>
-          <a:lnRef idx="1">
-            <a:schemeClr val="accent1"/>
-          </a:lnRef>
-          <a:fillRef idx="3">
-            <a:schemeClr val="accent1"/>
-          </a:fillRef>
-          <a:effectRef idx="2">
-            <a:schemeClr val="accent1"/>
-          </a:effectRef>
-          <a:fontRef idx="minor">
-            <a:schemeClr val="lt1"/>
-          </a:fontRef>
-        </p:style>
-        <p:txBody>
-          <a:bodyPr rtlCol="0" anchor="ctr" wrap="square"/>
-          <a:lstStyle/>
-          <a:p>
-            <a:pPr algn="ctr">
-              <a:defRPr sz="1700" b="1">
-                <a:solidFill>
-                  <a:srgbClr val="4678E8"/>
-                </a:solidFill>
-                <a:latin typeface="Space Grotesk"/>
-              </a:defRPr>
-            </a:pPr>
-            <a:r>
-              <a:t>Risk Desk returns verdict</a:t>
-            </a:r>
-          </a:p>
-          <a:p>
-            <a:pPr>
-              <a:defRPr sz="1300">
-                <a:solidFill>
-                  <a:srgbClr val="1F242E"/>
-                </a:solidFill>
-                <a:latin typeface="Arial"/>
-              </a:defRPr>
-            </a:pPr>
-            <a:r>
-              <a:t>The decision is an Assessment, not a model confidence score.</a:t>
+              <a:t>Asks 5 units of an open-mint token</a:t>
+            </a:r>
+            <a:br/>
+            <a:r>
+              <a:t>Address: 1 tx, first seen that day</a:t>
+            </a:r>
+            <a:br/>
+            <a:r>
+              <a:t>Risk check fad4fce2...</a:t>
+            </a:r>
+            <a:br/>
+            <a:r>
+              <a:t>Not paid: asset-mint-open</a:t>
             </a:r>
           </a:p>
         </p:txBody>
@@ -3608,13 +3632,13 @@
         <p:spPr>
           <a:xfrm>
             <a:off x="8138160" y="2240280"/>
-            <a:ext cx="3429000" cy="2377440"/>
+            <a:ext cx="3429000" cy="2651760"/>
           </a:xfrm>
           <a:prstGeom prst="rect">
             <a:avLst/>
           </a:prstGeom>
           <a:solidFill>
-            <a:srgbClr val="F8F9FB"/>
+            <a:srgbClr val="222731"/>
           </a:solidFill>
           <a:ln w="15240">
             <a:solidFill>
@@ -3643,34 +3667,38 @@
             <a:pPr algn="ctr">
               <a:defRPr sz="1700" b="1">
                 <a:solidFill>
-                  <a:srgbClr val="1F242E"/>
+                  <a:srgbClr val="F8F9FB"/>
                 </a:solidFill>
                 <a:latin typeface="Space Grotesk"/>
               </a:defRPr>
             </a:pPr>
             <a:r>
-              <a:t>Agent branches</a:t>
+              <a:t>Production endpoint</a:t>
             </a:r>
           </a:p>
           <a:p>
             <a:pPr>
               <a:defRPr sz="1300">
                 <a:solidFill>
-                  <a:srgbClr val="1F242E"/>
-                </a:solidFill>
-                <a:latin typeface="Arial"/>
-              </a:defRPr>
-            </a:pPr>
-            <a:r>
-              <a:t>INTERACT → pay seller</a:t>
+                  <a:srgbClr val="F8F9FB"/>
+                </a:solidFill>
+                <a:latin typeface="Courier New"/>
+              </a:defRPr>
+            </a:pPr>
+            <a:r>
+              <a:t>Live Vercel x402 call</a:t>
             </a:r>
             <a:br/>
             <a:r>
-              <a:t>CONDITIONS → inspect</a:t>
+              <a:t>Payment 66d28ffb...</a:t>
             </a:r>
             <a:br/>
             <a:r>
-              <a:t>DO NOT INTERACT → refuse</a:t>
+              <a:t>Verdict INTERACT, HTTP 200</a:t>
+            </a:r>
+            <a:br/>
+            <a:r>
+              <a:t>Same payment replayed: 409</a:t>
             </a:r>
           </a:p>
         </p:txBody>
@@ -3683,7 +3711,7 @@
         </p:nvSpPr>
         <p:spPr>
           <a:xfrm>
-            <a:off x="640080" y="5074920"/>
+            <a:off x="640080" y="5257800"/>
             <a:ext cx="10698480" cy="411480"/>
           </a:xfrm>
           <a:prstGeom prst="rect">
@@ -3706,7 +3734,7 @@
               </a:defRPr>
             </a:pPr>
             <a:r>
-              <a:t>The proof is the branch: evidence changes whether value moves.</a:t>
+              <a:t>The proof is the branch: evidence decides whether value moves.</a:t>
             </a:r>
           </a:p>
         </p:txBody>

</xml_diff>

<commit_message>
Rewrite Cardano risk pitch deck
</commit_message>
<xml_diff>
--- a/deck/cardano-risk-analyst.pptx
+++ b/deck/cardano-risk-analyst.pptx
@@ -15,7 +15,6 @@
     <p:sldId id="263" r:id="rId14"/>
     <p:sldId id="264" r:id="rId15"/>
     <p:sldId id="265" r:id="rId16"/>
-    <p:sldId id="266" r:id="rId17"/>
   </p:sldIdLst>
   <p:sldSz cx="12188952" cy="6858000" type="screen4x3"/>
   <p:notesSz cx="6858000" cy="9144000"/>
@@ -3114,8 +3113,8 @@
         </p:nvSpPr>
         <p:spPr>
           <a:xfrm>
-            <a:off x="731520" y="1325880"/>
-            <a:ext cx="10698480" cy="822960"/>
+            <a:off x="731520" y="1143000"/>
+            <a:ext cx="10698480" cy="1417320"/>
           </a:xfrm>
           <a:prstGeom prst="rect">
             <a:avLst/>
@@ -3129,7 +3128,7 @@
           <a:lstStyle/>
           <a:p>
             <a:pPr algn="ctr">
-              <a:defRPr sz="4200" b="1">
+              <a:defRPr sz="4000" b="1">
                 <a:solidFill>
                   <a:srgbClr val="1F242E"/>
                 </a:solidFill>
@@ -3137,7 +3136,7 @@
               </a:defRPr>
             </a:pPr>
             <a:r>
-              <a:t>An approval step before your agent</a:t>
+              <a:t>An approval step before your agent pays anyone on Cardano</a:t>
             </a:r>
           </a:p>
         </p:txBody>
@@ -3150,8 +3149,8 @@
         </p:nvSpPr>
         <p:spPr>
           <a:xfrm>
-            <a:off x="731520" y="2148840"/>
-            <a:ext cx="10698480" cy="822960"/>
+            <a:off x="1508760" y="3246120"/>
+            <a:ext cx="9144000" cy="548640"/>
           </a:xfrm>
           <a:prstGeom prst="rect">
             <a:avLst/>
@@ -3165,15 +3164,15 @@
           <a:lstStyle/>
           <a:p>
             <a:pPr algn="ctr">
-              <a:defRPr sz="4200" b="1">
-                <a:solidFill>
-                  <a:srgbClr val="4678E8"/>
-                </a:solidFill>
-                <a:latin typeface="Space Grotesk"/>
-              </a:defRPr>
-            </a:pPr>
-            <a:r>
-              <a:t>pays anyone on Cardano.</a:t>
+              <a:defRPr sz="2000" b="0">
+                <a:solidFill>
+                  <a:srgbClr val="1F242E"/>
+                </a:solidFill>
+                <a:latin typeface="Inter"/>
+              </a:defRPr>
+            </a:pPr>
+            <a:r>
+              <a:t>A paid check between the seller’s request and the wallet signature.</a:t>
             </a:r>
           </a:p>
         </p:txBody>
@@ -3186,8 +3185,8 @@
         </p:nvSpPr>
         <p:spPr>
           <a:xfrm>
-            <a:off x="1508760" y="3520440"/>
-            <a:ext cx="9144000" cy="548640"/>
+            <a:off x="2971800" y="4709160"/>
+            <a:ext cx="6217920" cy="411480"/>
           </a:xfrm>
           <a:prstGeom prst="rect">
             <a:avLst/>
@@ -3201,15 +3200,15 @@
           <a:lstStyle/>
           <a:p>
             <a:pPr algn="ctr">
-              <a:defRPr sz="2000" b="0">
-                <a:solidFill>
-                  <a:srgbClr val="1F242E"/>
-                </a:solidFill>
-                <a:latin typeface="Arial"/>
-              </a:defRPr>
-            </a:pPr>
-            <a:r>
-              <a:t>Cardano Risk Analyst is the paid preflight check before value moves.</a:t>
+              <a:defRPr sz="1200" b="1">
+                <a:solidFill>
+                  <a:srgbClr val="5A6472"/>
+                </a:solidFill>
+                <a:latin typeface="JetBrains Mono"/>
+              </a:defRPr>
+            </a:pPr>
+            <a:r>
+              <a:t>ARROW KEYS TO READ  /  P TO OPEN THE HUMAN UI</a:t>
             </a:r>
           </a:p>
         </p:txBody>
@@ -3222,8 +3221,8 @@
         </p:nvSpPr>
         <p:spPr>
           <a:xfrm>
-            <a:off x="2971800" y="4800600"/>
-            <a:ext cx="6217920" cy="411480"/>
+            <a:off x="10744200" y="6355080"/>
+            <a:ext cx="777240" cy="228600"/>
           </a:xfrm>
           <a:prstGeom prst="rect">
             <a:avLst/>
@@ -3236,52 +3235,16 @@
           </a:bodyPr>
           <a:lstStyle/>
           <a:p>
-            <a:pPr algn="ctr">
-              <a:defRPr sz="1200" b="1">
-                <a:solidFill>
-                  <a:srgbClr val="5A6472"/>
-                </a:solidFill>
-                <a:latin typeface="Courier New"/>
-              </a:defRPr>
-            </a:pPr>
-            <a:r>
-              <a:t>ARROW KEYS TO READ  /  P TO OPEN THE HUMAN UI</a:t>
-            </a:r>
-          </a:p>
-        </p:txBody>
-      </p:sp>
-      <p:sp>
-        <p:nvSpPr>
-          <p:cNvPr id="6" name="TextBox 5"/>
-          <p:cNvSpPr txBox="1"/>
-          <p:nvPr/>
-        </p:nvSpPr>
-        <p:spPr>
-          <a:xfrm>
-            <a:off x="640080" y="6355080"/>
-            <a:ext cx="10881360" cy="228600"/>
-          </a:xfrm>
-          <a:prstGeom prst="rect">
-            <a:avLst/>
-          </a:prstGeom>
-          <a:noFill/>
-        </p:spPr>
-        <p:txBody>
-          <a:bodyPr wrap="square">
-            <a:spAutoFit/>
-          </a:bodyPr>
-          <a:lstStyle/>
-          <a:p>
             <a:pPr algn="r">
               <a:defRPr sz="1000" b="0">
                 <a:solidFill>
                   <a:srgbClr val="5A6472"/>
                 </a:solidFill>
-                <a:latin typeface="Courier New"/>
-              </a:defRPr>
-            </a:pPr>
-            <a:r>
-              <a:t>01 / 11</a:t>
+                <a:latin typeface="JetBrains Mono"/>
+              </a:defRPr>
+            </a:pPr>
+            <a:r>
+              <a:t>01 / 10</a:t>
             </a:r>
           </a:p>
         </p:txBody>
@@ -3320,8 +3283,8 @@
         </p:nvSpPr>
         <p:spPr>
           <a:xfrm>
-            <a:off x="640080" y="411480"/>
-            <a:ext cx="10698480" cy="594360"/>
+            <a:off x="731520" y="1005840"/>
+            <a:ext cx="10698480" cy="256032"/>
           </a:xfrm>
           <a:prstGeom prst="rect">
             <a:avLst/>
@@ -3335,72 +3298,29 @@
           <a:lstStyle/>
           <a:p>
             <a:pPr algn="l">
-              <a:defRPr sz="3400" b="1">
-                <a:solidFill>
-                  <a:srgbClr val="1F242E"/>
-                </a:solidFill>
-                <a:latin typeface="Space Grotesk"/>
-              </a:defRPr>
-            </a:pPr>
-            <a:r>
-              <a:t>One agent paid one seller and refused the other</a:t>
-            </a:r>
-          </a:p>
-        </p:txBody>
-      </p:sp>
-      <p:sp>
-        <p:nvSpPr>
-          <p:cNvPr id="3" name="Rectangle 2"/>
-          <p:cNvSpPr/>
-          <p:nvPr/>
-        </p:nvSpPr>
-        <p:spPr>
-          <a:xfrm>
-            <a:off x="640080" y="1115568"/>
-            <a:ext cx="822960" cy="64008"/>
-          </a:xfrm>
-          <a:prstGeom prst="rect">
-            <a:avLst/>
-          </a:prstGeom>
-          <a:solidFill>
-            <a:srgbClr val="4678E8"/>
-          </a:solidFill>
-          <a:ln>
-            <a:noFill/>
-          </a:ln>
-        </p:spPr>
-        <p:style>
-          <a:lnRef idx="1">
-            <a:schemeClr val="accent1"/>
-          </a:lnRef>
-          <a:fillRef idx="3">
-            <a:schemeClr val="accent1"/>
-          </a:fillRef>
-          <a:effectRef idx="2">
-            <a:schemeClr val="accent1"/>
-          </a:effectRef>
-          <a:fontRef idx="minor">
-            <a:schemeClr val="lt1"/>
-          </a:fontRef>
-        </p:style>
-        <p:txBody>
-          <a:bodyPr rtlCol="0" anchor="ctr"/>
-          <a:lstStyle/>
-          <a:p>
-            <a:pPr algn="ctr"/>
-          </a:p>
-        </p:txBody>
-      </p:sp>
-      <p:sp>
-        <p:nvSpPr>
-          <p:cNvPr id="4" name="TextBox 3"/>
+              <a:defRPr sz="1000" b="0">
+                <a:solidFill>
+                  <a:srgbClr val="5A6472"/>
+                </a:solidFill>
+                <a:latin typeface="JetBrains Mono"/>
+              </a:defRPr>
+            </a:pPr>
+            <a:r>
+              <a:t>CLOSE</a:t>
+            </a:r>
+          </a:p>
+        </p:txBody>
+      </p:sp>
+      <p:sp>
+        <p:nvSpPr>
+          <p:cNvPr id="3" name="TextBox 2"/>
           <p:cNvSpPr txBox="1"/>
           <p:nvPr/>
         </p:nvSpPr>
         <p:spPr>
           <a:xfrm>
-            <a:off x="10744200" y="6355080"/>
-            <a:ext cx="777240" cy="228600"/>
+            <a:off x="731520" y="1508760"/>
+            <a:ext cx="10698480" cy="1143000"/>
           </a:xfrm>
           <a:prstGeom prst="rect">
             <a:avLst/>
@@ -3413,30 +3333,30 @@
           </a:bodyPr>
           <a:lstStyle/>
           <a:p>
-            <a:pPr algn="r">
-              <a:defRPr sz="1000" b="0">
-                <a:solidFill>
-                  <a:srgbClr val="5A6472"/>
-                </a:solidFill>
-                <a:latin typeface="Courier New"/>
-              </a:defRPr>
-            </a:pPr>
-            <a:r>
-              <a:t>10 / 11</a:t>
-            </a:r>
-          </a:p>
-        </p:txBody>
-      </p:sp>
-      <p:sp>
-        <p:nvSpPr>
-          <p:cNvPr id="5" name="TextBox 4"/>
+            <a:pPr algn="ctr">
+              <a:defRPr sz="4200" b="1">
+                <a:solidFill>
+                  <a:srgbClr val="1F242E"/>
+                </a:solidFill>
+                <a:latin typeface="Space Grotesk"/>
+              </a:defRPr>
+            </a:pPr>
+            <a:r>
+              <a:t>Let the agent move fast. Make the wallet ask first.</a:t>
+            </a:r>
+          </a:p>
+        </p:txBody>
+      </p:sp>
+      <p:sp>
+        <p:nvSpPr>
+          <p:cNvPr id="4" name="TextBox 3"/>
           <p:cNvSpPr txBox="1"/>
           <p:nvPr/>
         </p:nvSpPr>
         <p:spPr>
           <a:xfrm>
-            <a:off x="640080" y="1508760"/>
-            <a:ext cx="10698480" cy="502920"/>
+            <a:off x="1508760" y="3154680"/>
+            <a:ext cx="9144000" cy="548640"/>
           </a:xfrm>
           <a:prstGeom prst="rect">
             <a:avLst/>
@@ -3449,269 +3369,29 @@
           </a:bodyPr>
           <a:lstStyle/>
           <a:p>
-            <a:pPr algn="l">
-              <a:defRPr sz="2100" b="0">
+            <a:pPr algn="ctr">
+              <a:defRPr sz="1900" b="0">
                 <a:solidFill>
                   <a:srgbClr val="1F242E"/>
                 </a:solidFill>
-                <a:latin typeface="Arial"/>
-              </a:defRPr>
-            </a:pPr>
-            <a:r>
-              <a:t>Before paying either seller, the agent paid the Risk Desk 1 ADA over x402 and acted on the verdict.</a:t>
-            </a:r>
-          </a:p>
-        </p:txBody>
-      </p:sp>
-      <p:sp>
-        <p:nvSpPr>
-          <p:cNvPr id="6" name="Rectangle 5"/>
-          <p:cNvSpPr/>
-          <p:nvPr/>
-        </p:nvSpPr>
-        <p:spPr>
-          <a:xfrm>
-            <a:off x="640080" y="2240280"/>
-            <a:ext cx="3429000" cy="2651760"/>
-          </a:xfrm>
-          <a:prstGeom prst="rect">
-            <a:avLst/>
-          </a:prstGeom>
-          <a:solidFill>
-            <a:srgbClr val="F8F9FB"/>
-          </a:solidFill>
-          <a:ln w="15240">
-            <a:solidFill>
-              <a:srgbClr val="4678E8"/>
-            </a:solidFill>
-          </a:ln>
-        </p:spPr>
-        <p:style>
-          <a:lnRef idx="1">
-            <a:schemeClr val="accent1"/>
-          </a:lnRef>
-          <a:fillRef idx="3">
-            <a:schemeClr val="accent1"/>
-          </a:fillRef>
-          <a:effectRef idx="2">
-            <a:schemeClr val="accent1"/>
-          </a:effectRef>
-          <a:fontRef idx="minor">
-            <a:schemeClr val="lt1"/>
-          </a:fontRef>
-        </p:style>
-        <p:txBody>
-          <a:bodyPr rtlCol="0" anchor="ctr" wrap="square"/>
-          <a:lstStyle/>
-          <a:p>
-            <a:pPr algn="ctr">
-              <a:defRPr sz="1700" b="1">
-                <a:solidFill>
-                  <a:srgbClr val="4678E8"/>
-                </a:solidFill>
-                <a:latin typeface="Space Grotesk"/>
-              </a:defRPr>
-            </a:pPr>
-            <a:r>
-              <a:t>Seller A  /  INTERACT</a:t>
-            </a:r>
-          </a:p>
-          <a:p>
-            <a:pPr>
-              <a:defRPr sz="1300">
-                <a:solidFill>
-                  <a:srgbClr val="1F242E"/>
-                </a:solidFill>
-                <a:latin typeface="Arial"/>
-              </a:defRPr>
-            </a:pPr>
-            <a:r>
-              <a:t>Asks 2 ADA</a:t>
-            </a:r>
-            <a:br/>
-            <a:r>
-              <a:t>Wallet: 27 txs since 5 Oct</a:t>
-            </a:r>
-            <a:br/>
-            <a:r>
-              <a:t>Risk check fc053ce1...</a:t>
-            </a:r>
-            <a:br/>
-            <a:r>
-              <a:t>Paid 3866ed31...</a:t>
-            </a:r>
-          </a:p>
-        </p:txBody>
-      </p:sp>
-      <p:sp>
-        <p:nvSpPr>
-          <p:cNvPr id="7" name="Rectangle 6"/>
-          <p:cNvSpPr/>
-          <p:nvPr/>
-        </p:nvSpPr>
-        <p:spPr>
-          <a:xfrm>
-            <a:off x="4389120" y="2240280"/>
-            <a:ext cx="3429000" cy="2651760"/>
-          </a:xfrm>
-          <a:prstGeom prst="rect">
-            <a:avLst/>
-          </a:prstGeom>
-          <a:solidFill>
-            <a:srgbClr val="F8F9FB"/>
-          </a:solidFill>
-          <a:ln w="15240">
-            <a:solidFill>
-              <a:srgbClr val="C9D1DD"/>
-            </a:solidFill>
-          </a:ln>
-        </p:spPr>
-        <p:style>
-          <a:lnRef idx="1">
-            <a:schemeClr val="accent1"/>
-          </a:lnRef>
-          <a:fillRef idx="3">
-            <a:schemeClr val="accent1"/>
-          </a:fillRef>
-          <a:effectRef idx="2">
-            <a:schemeClr val="accent1"/>
-          </a:effectRef>
-          <a:fontRef idx="minor">
-            <a:schemeClr val="lt1"/>
-          </a:fontRef>
-        </p:style>
-        <p:txBody>
-          <a:bodyPr rtlCol="0" anchor="ctr" wrap="square"/>
-          <a:lstStyle/>
-          <a:p>
-            <a:pPr algn="ctr">
-              <a:defRPr sz="1700" b="1">
-                <a:solidFill>
-                  <a:srgbClr val="1F242E"/>
-                </a:solidFill>
-                <a:latin typeface="Space Grotesk"/>
-              </a:defRPr>
-            </a:pPr>
-            <a:r>
-              <a:t>Seller B  /  DO NOT INTERACT</a:t>
-            </a:r>
-          </a:p>
-          <a:p>
-            <a:pPr>
-              <a:defRPr sz="1300">
-                <a:solidFill>
-                  <a:srgbClr val="1F242E"/>
-                </a:solidFill>
-                <a:latin typeface="Arial"/>
-              </a:defRPr>
-            </a:pPr>
-            <a:r>
-              <a:t>Asks 5 units of an open-mint token</a:t>
-            </a:r>
-            <a:br/>
-            <a:r>
-              <a:t>Address: 1 tx, first seen that day</a:t>
-            </a:r>
-            <a:br/>
-            <a:r>
-              <a:t>Risk check fad4fce2...</a:t>
-            </a:r>
-            <a:br/>
-            <a:r>
-              <a:t>Not paid: asset-mint-open</a:t>
-            </a:r>
-          </a:p>
-        </p:txBody>
-      </p:sp>
-      <p:sp>
-        <p:nvSpPr>
-          <p:cNvPr id="8" name="Rectangle 7"/>
-          <p:cNvSpPr/>
-          <p:nvPr/>
-        </p:nvSpPr>
-        <p:spPr>
-          <a:xfrm>
-            <a:off x="8138160" y="2240280"/>
-            <a:ext cx="3429000" cy="2651760"/>
-          </a:xfrm>
-          <a:prstGeom prst="rect">
-            <a:avLst/>
-          </a:prstGeom>
-          <a:solidFill>
-            <a:srgbClr val="222731"/>
-          </a:solidFill>
-          <a:ln w="15240">
-            <a:solidFill>
-              <a:srgbClr val="C9D1DD"/>
-            </a:solidFill>
-          </a:ln>
-        </p:spPr>
-        <p:style>
-          <a:lnRef idx="1">
-            <a:schemeClr val="accent1"/>
-          </a:lnRef>
-          <a:fillRef idx="3">
-            <a:schemeClr val="accent1"/>
-          </a:fillRef>
-          <a:effectRef idx="2">
-            <a:schemeClr val="accent1"/>
-          </a:effectRef>
-          <a:fontRef idx="minor">
-            <a:schemeClr val="lt1"/>
-          </a:fontRef>
-        </p:style>
-        <p:txBody>
-          <a:bodyPr rtlCol="0" anchor="ctr" wrap="square"/>
-          <a:lstStyle/>
-          <a:p>
-            <a:pPr algn="ctr">
-              <a:defRPr sz="1700" b="1">
-                <a:solidFill>
-                  <a:srgbClr val="F8F9FB"/>
-                </a:solidFill>
-                <a:latin typeface="Space Grotesk"/>
-              </a:defRPr>
-            </a:pPr>
-            <a:r>
-              <a:t>Production endpoint</a:t>
-            </a:r>
-          </a:p>
-          <a:p>
-            <a:pPr>
-              <a:defRPr sz="1300">
-                <a:solidFill>
-                  <a:srgbClr val="F8F9FB"/>
-                </a:solidFill>
-                <a:latin typeface="Courier New"/>
-              </a:defRPr>
-            </a:pPr>
-            <a:r>
-              <a:t>Live Vercel x402 call</a:t>
-            </a:r>
-            <a:br/>
-            <a:r>
-              <a:t>Payment 66d28ffb...</a:t>
-            </a:r>
-            <a:br/>
-            <a:r>
-              <a:t>Verdict INTERACT, HTTP 200</a:t>
-            </a:r>
-            <a:br/>
-            <a:r>
-              <a:t>Same payment replayed: 409</a:t>
-            </a:r>
-          </a:p>
-        </p:txBody>
-      </p:sp>
-      <p:sp>
-        <p:nvSpPr>
-          <p:cNvPr id="9" name="TextBox 8"/>
+                <a:latin typeface="Inter"/>
+              </a:defRPr>
+            </a:pPr>
+            <a:r>
+              <a:t>Cardano Risk Analyst is the approval step before an autonomous payment becomes an irreversible one.</a:t>
+            </a:r>
+          </a:p>
+        </p:txBody>
+      </p:sp>
+      <p:sp>
+        <p:nvSpPr>
+          <p:cNvPr id="5" name="TextBox 4"/>
           <p:cNvSpPr txBox="1"/>
           <p:nvPr/>
         </p:nvSpPr>
         <p:spPr>
           <a:xfrm>
-            <a:off x="640080" y="5257800"/>
+            <a:off x="640080" y="4800600"/>
             <a:ext cx="10698480" cy="411480"/>
           </a:xfrm>
           <a:prstGeom prst="rect">
@@ -3726,29 +3406,29 @@
           <a:lstStyle/>
           <a:p>
             <a:pPr algn="ctr">
-              <a:defRPr sz="1800" b="1">
-                <a:solidFill>
-                  <a:srgbClr val="1F242E"/>
-                </a:solidFill>
-                <a:latin typeface="Arial"/>
-              </a:defRPr>
-            </a:pPr>
-            <a:r>
-              <a:t>The proof is the branch: evidence decides whether value moves.</a:t>
-            </a:r>
-          </a:p>
-        </p:txBody>
-      </p:sp>
-      <p:sp>
-        <p:nvSpPr>
-          <p:cNvPr id="10" name="TextBox 9"/>
+              <a:defRPr sz="1500" b="1">
+                <a:solidFill>
+                  <a:srgbClr val="4678E8"/>
+                </a:solidFill>
+                <a:latin typeface="JetBrains Mono"/>
+              </a:defRPr>
+            </a:pPr>
+            <a:r>
+              <a:t>REQUEST   →   CHECK   →   APPROVE OR REFUSE</a:t>
+            </a:r>
+          </a:p>
+        </p:txBody>
+      </p:sp>
+      <p:sp>
+        <p:nvSpPr>
+          <p:cNvPr id="6" name="TextBox 5"/>
           <p:cNvSpPr txBox="1"/>
           <p:nvPr/>
         </p:nvSpPr>
         <p:spPr>
           <a:xfrm>
-            <a:off x="640080" y="6355080"/>
-            <a:ext cx="8686800" cy="228600"/>
+            <a:off x="10744200" y="6355080"/>
+            <a:ext cx="777240" cy="228600"/>
           </a:xfrm>
           <a:prstGeom prst="rect">
             <a:avLst/>
@@ -3761,381 +3441,16 @@
           </a:bodyPr>
           <a:lstStyle/>
           <a:p>
-            <a:pPr algn="l">
-              <a:defRPr sz="1000" b="0">
-                <a:solidFill>
-                  <a:srgbClr val="5A6472"/>
-                </a:solidFill>
-                <a:latin typeface="Courier New"/>
-              </a:defRPr>
-            </a:pPr>
-            <a:r>
-              <a:t>Cardano Risk Analyst  /  x402  /  Sokosumi  /  Masumi</a:t>
-            </a:r>
-          </a:p>
-        </p:txBody>
-      </p:sp>
-    </p:spTree>
-  </p:cSld>
-  <p:clrMapOvr>
-    <a:masterClrMapping/>
-  </p:clrMapOvr>
-</p:sld>
-</file>
-
-<file path=ppt/slides/slide11.xml><?xml version="1.0" encoding="utf-8"?>
-<p:sld xmlns:a="http://schemas.openxmlformats.org/drawingml/2006/main" xmlns:p="http://schemas.openxmlformats.org/presentationml/2006/main" xmlns:r="http://schemas.openxmlformats.org/officeDocument/2006/relationships">
-  <p:cSld>
-    <p:bg>
-      <p:bgPr>
-        <a:solidFill>
-          <a:srgbClr val="F8F9FB"/>
-        </a:solidFill>
-        <a:effectLst/>
-      </p:bgPr>
-    </p:bg>
-    <p:spTree>
-      <p:nvGrpSpPr>
-        <p:cNvPr id="1" name=""/>
-        <p:cNvGrpSpPr/>
-        <p:nvPr/>
-      </p:nvGrpSpPr>
-      <p:grpSpPr/>
-      <p:sp>
-        <p:nvSpPr>
-          <p:cNvPr id="2" name="TextBox 1"/>
-          <p:cNvSpPr txBox="1"/>
-          <p:nvPr/>
-        </p:nvSpPr>
-        <p:spPr>
-          <a:xfrm>
-            <a:off x="640080" y="411480"/>
-            <a:ext cx="10698480" cy="594360"/>
-          </a:xfrm>
-          <a:prstGeom prst="rect">
-            <a:avLst/>
-          </a:prstGeom>
-          <a:noFill/>
-        </p:spPr>
-        <p:txBody>
-          <a:bodyPr wrap="square">
-            <a:spAutoFit/>
-          </a:bodyPr>
-          <a:lstStyle/>
-          <a:p>
-            <a:pPr algn="l">
-              <a:defRPr sz="3400" b="1">
-                <a:solidFill>
-                  <a:srgbClr val="1F242E"/>
-                </a:solidFill>
-                <a:latin typeface="Space Grotesk"/>
-              </a:defRPr>
-            </a:pPr>
-            <a:r>
-              <a:t>Why Cardano and Masumi</a:t>
-            </a:r>
-          </a:p>
-        </p:txBody>
-      </p:sp>
-      <p:sp>
-        <p:nvSpPr>
-          <p:cNvPr id="3" name="Rectangle 2"/>
-          <p:cNvSpPr/>
-          <p:nvPr/>
-        </p:nvSpPr>
-        <p:spPr>
-          <a:xfrm>
-            <a:off x="640080" y="1115568"/>
-            <a:ext cx="822960" cy="64008"/>
-          </a:xfrm>
-          <a:prstGeom prst="rect">
-            <a:avLst/>
-          </a:prstGeom>
-          <a:solidFill>
-            <a:srgbClr val="4678E8"/>
-          </a:solidFill>
-          <a:ln>
-            <a:noFill/>
-          </a:ln>
-        </p:spPr>
-        <p:style>
-          <a:lnRef idx="1">
-            <a:schemeClr val="accent1"/>
-          </a:lnRef>
-          <a:fillRef idx="3">
-            <a:schemeClr val="accent1"/>
-          </a:fillRef>
-          <a:effectRef idx="2">
-            <a:schemeClr val="accent1"/>
-          </a:effectRef>
-          <a:fontRef idx="minor">
-            <a:schemeClr val="lt1"/>
-          </a:fontRef>
-        </p:style>
-        <p:txBody>
-          <a:bodyPr rtlCol="0" anchor="ctr"/>
-          <a:lstStyle/>
-          <a:p>
-            <a:pPr algn="ctr"/>
-          </a:p>
-        </p:txBody>
-      </p:sp>
-      <p:sp>
-        <p:nvSpPr>
-          <p:cNvPr id="4" name="TextBox 3"/>
-          <p:cNvSpPr txBox="1"/>
-          <p:nvPr/>
-        </p:nvSpPr>
-        <p:spPr>
-          <a:xfrm>
-            <a:off x="10744200" y="6355080"/>
-            <a:ext cx="777240" cy="228600"/>
-          </a:xfrm>
-          <a:prstGeom prst="rect">
-            <a:avLst/>
-          </a:prstGeom>
-          <a:noFill/>
-        </p:spPr>
-        <p:txBody>
-          <a:bodyPr wrap="square">
-            <a:spAutoFit/>
-          </a:bodyPr>
-          <a:lstStyle/>
-          <a:p>
             <a:pPr algn="r">
               <a:defRPr sz="1000" b="0">
                 <a:solidFill>
                   <a:srgbClr val="5A6472"/>
                 </a:solidFill>
-                <a:latin typeface="Courier New"/>
-              </a:defRPr>
-            </a:pPr>
-            <a:r>
-              <a:t>11 / 11</a:t>
-            </a:r>
-          </a:p>
-        </p:txBody>
-      </p:sp>
-      <p:sp>
-        <p:nvSpPr>
-          <p:cNvPr id="5" name="Rectangle 4"/>
-          <p:cNvSpPr/>
-          <p:nvPr/>
-        </p:nvSpPr>
-        <p:spPr>
-          <a:xfrm>
-            <a:off x="640080" y="1828800"/>
-            <a:ext cx="5212080" cy="2926080"/>
-          </a:xfrm>
-          <a:prstGeom prst="rect">
-            <a:avLst/>
-          </a:prstGeom>
-          <a:solidFill>
-            <a:srgbClr val="F8F9FB"/>
-          </a:solidFill>
-          <a:ln w="15240">
-            <a:solidFill>
-              <a:srgbClr val="4678E8"/>
-            </a:solidFill>
-          </a:ln>
-        </p:spPr>
-        <p:style>
-          <a:lnRef idx="1">
-            <a:schemeClr val="accent1"/>
-          </a:lnRef>
-          <a:fillRef idx="3">
-            <a:schemeClr val="accent1"/>
-          </a:fillRef>
-          <a:effectRef idx="2">
-            <a:schemeClr val="accent1"/>
-          </a:effectRef>
-          <a:fontRef idx="minor">
-            <a:schemeClr val="lt1"/>
-          </a:fontRef>
-        </p:style>
-        <p:txBody>
-          <a:bodyPr rtlCol="0" anchor="ctr" wrap="square"/>
-          <a:lstStyle/>
-          <a:p>
-            <a:pPr algn="ctr">
-              <a:defRPr sz="1700" b="1">
-                <a:solidFill>
-                  <a:srgbClr val="4678E8"/>
-                </a:solidFill>
-                <a:latin typeface="Space Grotesk"/>
-              </a:defRPr>
-            </a:pPr>
-            <a:r>
-              <a:t>Cardano</a:t>
-            </a:r>
-          </a:p>
-          <a:p>
-            <a:pPr>
-              <a:defRPr sz="1300">
-                <a:solidFill>
-                  <a:srgbClr val="1F242E"/>
-                </a:solidFill>
-                <a:latin typeface="Arial"/>
-              </a:defRPr>
-            </a:pPr>
-            <a:r>
-              <a:t>Native assets carry minting policy evidence.</a:t>
-            </a:r>
-            <a:br/>
-            <a:r>
-              <a:t>Plutus scripts expose protocol surfaces.</a:t>
-            </a:r>
-            <a:br/>
-            <a:r>
-              <a:t>Koios and protocol APIs give the report its sources.</a:t>
-            </a:r>
-          </a:p>
-        </p:txBody>
-      </p:sp>
-      <p:sp>
-        <p:nvSpPr>
-          <p:cNvPr id="6" name="Rectangle 5"/>
-          <p:cNvSpPr/>
-          <p:nvPr/>
-        </p:nvSpPr>
-        <p:spPr>
-          <a:xfrm>
-            <a:off x="6217920" y="1828800"/>
-            <a:ext cx="5303520" cy="2926080"/>
-          </a:xfrm>
-          <a:prstGeom prst="rect">
-            <a:avLst/>
-          </a:prstGeom>
-          <a:solidFill>
-            <a:srgbClr val="F8F9FB"/>
-          </a:solidFill>
-          <a:ln w="15240">
-            <a:solidFill>
-              <a:srgbClr val="C9D1DD"/>
-            </a:solidFill>
-          </a:ln>
-        </p:spPr>
-        <p:style>
-          <a:lnRef idx="1">
-            <a:schemeClr val="accent1"/>
-          </a:lnRef>
-          <a:fillRef idx="3">
-            <a:schemeClr val="accent1"/>
-          </a:fillRef>
-          <a:effectRef idx="2">
-            <a:schemeClr val="accent1"/>
-          </a:effectRef>
-          <a:fontRef idx="minor">
-            <a:schemeClr val="lt1"/>
-          </a:fontRef>
-        </p:style>
-        <p:txBody>
-          <a:bodyPr rtlCol="0" anchor="ctr" wrap="square"/>
-          <a:lstStyle/>
-          <a:p>
-            <a:pPr algn="ctr">
-              <a:defRPr sz="1700" b="1">
-                <a:solidFill>
-                  <a:srgbClr val="1F242E"/>
-                </a:solidFill>
-                <a:latin typeface="Space Grotesk"/>
-              </a:defRPr>
-            </a:pPr>
-            <a:r>
-              <a:t>Masumi</a:t>
-            </a:r>
-          </a:p>
-          <a:p>
-            <a:pPr>
-              <a:defRPr sz="1300">
-                <a:solidFill>
-                  <a:srgbClr val="1F242E"/>
-                </a:solidFill>
-                <a:latin typeface="Arial"/>
-              </a:defRPr>
-            </a:pPr>
-            <a:r>
-              <a:t>Sokosumi makes the Coworker discoverable.</a:t>
-            </a:r>
-            <a:br/>
-            <a:r>
-              <a:t>Tasks make the read accountable.</a:t>
-            </a:r>
-            <a:br/>
-            <a:r>
-              <a:t>Escrow turns the evidence into paid work.</a:t>
-            </a:r>
-          </a:p>
-        </p:txBody>
-      </p:sp>
-      <p:sp>
-        <p:nvSpPr>
-          <p:cNvPr id="7" name="TextBox 6"/>
-          <p:cNvSpPr txBox="1"/>
-          <p:nvPr/>
-        </p:nvSpPr>
-        <p:spPr>
-          <a:xfrm>
-            <a:off x="640080" y="5257800"/>
-            <a:ext cx="10698480" cy="411480"/>
-          </a:xfrm>
-          <a:prstGeom prst="rect">
-            <a:avLst/>
-          </a:prstGeom>
-          <a:noFill/>
-        </p:spPr>
-        <p:txBody>
-          <a:bodyPr wrap="square">
-            <a:spAutoFit/>
-          </a:bodyPr>
-          <a:lstStyle/>
-          <a:p>
-            <a:pPr algn="ctr">
-              <a:defRPr sz="1800" b="1">
-                <a:solidFill>
-                  <a:srgbClr val="1F242E"/>
-                </a:solidFill>
-                <a:latin typeface="Arial"/>
-              </a:defRPr>
-            </a:pPr>
-            <a:r>
-              <a:t>Agents do not need to understand Cardano before they spend. They can hire a Coworker that does.</a:t>
-            </a:r>
-          </a:p>
-        </p:txBody>
-      </p:sp>
-      <p:sp>
-        <p:nvSpPr>
-          <p:cNvPr id="8" name="TextBox 7"/>
-          <p:cNvSpPr txBox="1"/>
-          <p:nvPr/>
-        </p:nvSpPr>
-        <p:spPr>
-          <a:xfrm>
-            <a:off x="640080" y="6355080"/>
-            <a:ext cx="8686800" cy="228600"/>
-          </a:xfrm>
-          <a:prstGeom prst="rect">
-            <a:avLst/>
-          </a:prstGeom>
-          <a:noFill/>
-        </p:spPr>
-        <p:txBody>
-          <a:bodyPr wrap="square">
-            <a:spAutoFit/>
-          </a:bodyPr>
-          <a:lstStyle/>
-          <a:p>
-            <a:pPr algn="l">
-              <a:defRPr sz="1000" b="0">
-                <a:solidFill>
-                  <a:srgbClr val="5A6472"/>
-                </a:solidFill>
-                <a:latin typeface="Courier New"/>
-              </a:defRPr>
-            </a:pPr>
-            <a:r>
-              <a:t>Cardano Risk Analyst  /  x402  /  Sokosumi  /  Masumi</a:t>
+                <a:latin typeface="JetBrains Mono"/>
+              </a:defRPr>
+            </a:pPr>
+            <a:r>
+              <a:t>10 / 10</a:t>
             </a:r>
           </a:p>
         </p:txBody>
@@ -4174,8 +3489,8 @@
         </p:nvSpPr>
         <p:spPr>
           <a:xfrm>
-            <a:off x="640080" y="411480"/>
-            <a:ext cx="10698480" cy="594360"/>
+            <a:off x="640080" y="365760"/>
+            <a:ext cx="10698480" cy="256032"/>
           </a:xfrm>
           <a:prstGeom prst="rect">
             <a:avLst/>
@@ -4189,7 +3504,43 @@
           <a:lstStyle/>
           <a:p>
             <a:pPr algn="l">
-              <a:defRPr sz="3400" b="1">
+              <a:defRPr sz="1000" b="0">
+                <a:solidFill>
+                  <a:srgbClr val="5A6472"/>
+                </a:solidFill>
+                <a:latin typeface="JetBrains Mono"/>
+              </a:defRPr>
+            </a:pPr>
+            <a:r>
+              <a:t>THE FEAR</a:t>
+            </a:r>
+          </a:p>
+        </p:txBody>
+      </p:sp>
+      <p:sp>
+        <p:nvSpPr>
+          <p:cNvPr id="3" name="TextBox 2"/>
+          <p:cNvSpPr txBox="1"/>
+          <p:nvPr/>
+        </p:nvSpPr>
+        <p:spPr>
+          <a:xfrm>
+            <a:off x="640080" y="749808"/>
+            <a:ext cx="10698480" cy="658368"/>
+          </a:xfrm>
+          <a:prstGeom prst="rect">
+            <a:avLst/>
+          </a:prstGeom>
+          <a:noFill/>
+        </p:spPr>
+        <p:txBody>
+          <a:bodyPr wrap="square">
+            <a:spAutoFit/>
+          </a:bodyPr>
+          <a:lstStyle/>
+          <a:p>
+            <a:pPr algn="l">
+              <a:defRPr sz="3100" b="1">
                 <a:solidFill>
                   <a:srgbClr val="1F242E"/>
                 </a:solidFill>
@@ -4197,20 +3548,20 @@
               </a:defRPr>
             </a:pPr>
             <a:r>
-              <a:t>The decision comes before the transaction</a:t>
-            </a:r>
-          </a:p>
-        </p:txBody>
-      </p:sp>
-      <p:sp>
-        <p:nvSpPr>
-          <p:cNvPr id="3" name="Rectangle 2"/>
+              <a:t>Your agent holds the wallet. The seller controls the story.</a:t>
+            </a:r>
+          </a:p>
+        </p:txBody>
+      </p:sp>
+      <p:sp>
+        <p:nvSpPr>
+          <p:cNvPr id="4" name="Rectangle 3"/>
           <p:cNvSpPr/>
           <p:nvPr/>
         </p:nvSpPr>
         <p:spPr>
           <a:xfrm>
-            <a:off x="640080" y="1115568"/>
+            <a:off x="640080" y="1536192"/>
             <a:ext cx="822960" cy="64008"/>
           </a:xfrm>
           <a:prstGeom prst="rect">
@@ -4247,7 +3598,7 @@
       </p:sp>
       <p:sp>
         <p:nvSpPr>
-          <p:cNvPr id="4" name="TextBox 3"/>
+          <p:cNvPr id="5" name="TextBox 4"/>
           <p:cNvSpPr txBox="1"/>
           <p:nvPr/>
         </p:nvSpPr>
@@ -4272,24 +3623,24 @@
                 <a:solidFill>
                   <a:srgbClr val="5A6472"/>
                 </a:solidFill>
-                <a:latin typeface="Courier New"/>
-              </a:defRPr>
-            </a:pPr>
-            <a:r>
-              <a:t>02 / 11</a:t>
-            </a:r>
-          </a:p>
-        </p:txBody>
-      </p:sp>
-      <p:sp>
-        <p:nvSpPr>
-          <p:cNvPr id="5" name="TextBox 4"/>
+                <a:latin typeface="JetBrains Mono"/>
+              </a:defRPr>
+            </a:pPr>
+            <a:r>
+              <a:t>02 / 10</a:t>
+            </a:r>
+          </a:p>
+        </p:txBody>
+      </p:sp>
+      <p:sp>
+        <p:nvSpPr>
+          <p:cNvPr id="6" name="TextBox 5"/>
           <p:cNvSpPr txBox="1"/>
           <p:nvPr/>
         </p:nvSpPr>
         <p:spPr>
           <a:xfrm>
-            <a:off x="640080" y="1508760"/>
+            <a:off x="640080" y="1783080"/>
             <a:ext cx="10698480" cy="502920"/>
           </a:xfrm>
           <a:prstGeom prst="rect">
@@ -4304,28 +3655,28 @@
           <a:lstStyle/>
           <a:p>
             <a:pPr algn="l">
-              <a:defRPr sz="2300" b="0">
+              <a:defRPr sz="1900" b="0">
                 <a:solidFill>
                   <a:srgbClr val="1F242E"/>
                 </a:solidFill>
-                <a:latin typeface="Arial"/>
-              </a:defRPr>
-            </a:pPr>
-            <a:r>
-              <a:t>A counterparty is the thing your agent is about to send value into.</a:t>
-            </a:r>
-          </a:p>
-        </p:txBody>
-      </p:sp>
-      <p:sp>
-        <p:nvSpPr>
-          <p:cNvPr id="6" name="Rectangle 5"/>
+                <a:latin typeface="Inter"/>
+              </a:defRPr>
+            </a:pPr>
+            <a:r>
+              <a:t>A payment request can name a real address, a real asset, and a real price while nobody has checked what sits behind them.</a:t>
+            </a:r>
+          </a:p>
+        </p:txBody>
+      </p:sp>
+      <p:sp>
+        <p:nvSpPr>
+          <p:cNvPr id="7" name="Rectangle 6"/>
           <p:cNvSpPr/>
           <p:nvPr/>
         </p:nvSpPr>
         <p:spPr>
           <a:xfrm>
-            <a:off x="640080" y="2331720"/>
+            <a:off x="640080" y="2743200"/>
             <a:ext cx="3429000" cy="2011680"/>
           </a:xfrm>
           <a:prstGeom prst="rect">
@@ -4367,7 +3718,7 @@
               </a:defRPr>
             </a:pPr>
             <a:r>
-              <a:t>Token</a:t>
+              <a:t>The agent sees</a:t>
             </a:r>
           </a:p>
           <a:p>
@@ -4376,24 +3727,24 @@
                 <a:solidFill>
                   <a:srgbClr val="1F242E"/>
                 </a:solidFill>
-                <a:latin typeface="Arial"/>
-              </a:defRPr>
-            </a:pPr>
-            <a:r>
-              <a:t>Mint policy, holders, registry identity, pool exit</a:t>
-            </a:r>
-          </a:p>
-        </p:txBody>
-      </p:sp>
-      <p:sp>
-        <p:nvSpPr>
-          <p:cNvPr id="7" name="Rectangle 6"/>
+                <a:latin typeface="Inter"/>
+              </a:defRPr>
+            </a:pPr>
+            <a:r>
+              <a:t>A 402 response with an amount, asset, payTo, and resource</a:t>
+            </a:r>
+          </a:p>
+        </p:txBody>
+      </p:sp>
+      <p:sp>
+        <p:nvSpPr>
+          <p:cNvPr id="8" name="Rectangle 7"/>
           <p:cNvSpPr/>
           <p:nvPr/>
         </p:nvSpPr>
         <p:spPr>
           <a:xfrm>
-            <a:off x="4389120" y="2331720"/>
+            <a:off x="4389120" y="2743200"/>
             <a:ext cx="3429000" cy="2011680"/>
           </a:xfrm>
           <a:prstGeom prst="rect">
@@ -4435,7 +3786,7 @@
               </a:defRPr>
             </a:pPr>
             <a:r>
-              <a:t>Script</a:t>
+              <a:t>The wallet can do</a:t>
             </a:r>
           </a:p>
           <a:p>
@@ -4444,24 +3795,24 @@
                 <a:solidFill>
                   <a:srgbClr val="1F242E"/>
                 </a:solidFill>
-                <a:latin typeface="Arial"/>
-              </a:defRPr>
-            </a:pPr>
-            <a:r>
-              <a:t>Protocol identity, TVL, UTxOs, recent transactions</a:t>
-            </a:r>
-          </a:p>
-        </p:txBody>
-      </p:sp>
-      <p:sp>
-        <p:nvSpPr>
-          <p:cNvPr id="8" name="Rectangle 7"/>
+                <a:latin typeface="Inter"/>
+              </a:defRPr>
+            </a:pPr>
+            <a:r>
+              <a:t>Sign and send value before a human inspects the counterparty</a:t>
+            </a:r>
+          </a:p>
+        </p:txBody>
+      </p:sp>
+      <p:sp>
+        <p:nvSpPr>
+          <p:cNvPr id="9" name="Rectangle 8"/>
           <p:cNvSpPr/>
           <p:nvPr/>
         </p:nvSpPr>
         <p:spPr>
           <a:xfrm>
-            <a:off x="8138160" y="2331720"/>
+            <a:off x="8138160" y="2743200"/>
             <a:ext cx="3429000" cy="2011680"/>
           </a:xfrm>
           <a:prstGeom prst="rect">
@@ -4503,7 +3854,7 @@
               </a:defRPr>
             </a:pPr>
             <a:r>
-              <a:t>x402 seller</a:t>
+              <a:t>The missing step</a:t>
             </a:r>
           </a:p>
           <a:p>
@@ -4512,25 +3863,25 @@
                 <a:solidFill>
                   <a:srgbClr val="1F242E"/>
                 </a:solidFill>
-                <a:latin typeface="Arial"/>
-              </a:defRPr>
-            </a:pPr>
-            <a:r>
-              <a:t>PayTo, asset, amount, resource, timeout</a:t>
-            </a:r>
-          </a:p>
-        </p:txBody>
-      </p:sp>
-      <p:sp>
-        <p:nvSpPr>
-          <p:cNvPr id="9" name="TextBox 8"/>
+                <a:latin typeface="Inter"/>
+              </a:defRPr>
+            </a:pPr>
+            <a:r>
+              <a:t>Check the asset policy, address history, and protocol surface before payment</a:t>
+            </a:r>
+          </a:p>
+        </p:txBody>
+      </p:sp>
+      <p:sp>
+        <p:nvSpPr>
+          <p:cNvPr id="10" name="TextBox 9"/>
           <p:cNvSpPr txBox="1"/>
           <p:nvPr/>
         </p:nvSpPr>
         <p:spPr>
           <a:xfrm>
-            <a:off x="640080" y="4983480"/>
-            <a:ext cx="10698480" cy="411480"/>
+            <a:off x="640080" y="6355080"/>
+            <a:ext cx="8686800" cy="228600"/>
           </a:xfrm>
           <a:prstGeom prst="rect">
             <a:avLst/>
@@ -4543,52 +3894,16 @@
           </a:bodyPr>
           <a:lstStyle/>
           <a:p>
-            <a:pPr algn="ctr">
-              <a:defRPr sz="1800" b="1">
-                <a:solidFill>
-                  <a:srgbClr val="1F242E"/>
-                </a:solidFill>
-                <a:latin typeface="Arial"/>
-              </a:defRPr>
-            </a:pPr>
-            <a:r>
-              <a:t>The output is one action: INTERACT, INTERACT WITH CONDITIONS, or DO NOT INTERACT.</a:t>
-            </a:r>
-          </a:p>
-        </p:txBody>
-      </p:sp>
-      <p:sp>
-        <p:nvSpPr>
-          <p:cNvPr id="10" name="TextBox 9"/>
-          <p:cNvSpPr txBox="1"/>
-          <p:nvPr/>
-        </p:nvSpPr>
-        <p:spPr>
-          <a:xfrm>
-            <a:off x="640080" y="6355080"/>
-            <a:ext cx="8686800" cy="228600"/>
-          </a:xfrm>
-          <a:prstGeom prst="rect">
-            <a:avLst/>
-          </a:prstGeom>
-          <a:noFill/>
-        </p:spPr>
-        <p:txBody>
-          <a:bodyPr wrap="square">
-            <a:spAutoFit/>
-          </a:bodyPr>
-          <a:lstStyle/>
-          <a:p>
             <a:pPr algn="l">
               <a:defRPr sz="1000" b="0">
                 <a:solidFill>
                   <a:srgbClr val="5A6472"/>
                 </a:solidFill>
-                <a:latin typeface="Courier New"/>
-              </a:defRPr>
-            </a:pPr>
-            <a:r>
-              <a:t>Cardano Risk Analyst  /  x402  /  Sokosumi  /  Masumi</a:t>
+                <a:latin typeface="JetBrains Mono"/>
+              </a:defRPr>
+            </a:pPr>
+            <a:r>
+              <a:t>Cardano Risk Desk  /  x402  /  Sokosumi  /  Masumi</a:t>
             </a:r>
           </a:p>
         </p:txBody>
@@ -4627,8 +3942,8 @@
         </p:nvSpPr>
         <p:spPr>
           <a:xfrm>
-            <a:off x="640080" y="411480"/>
-            <a:ext cx="10698480" cy="594360"/>
+            <a:off x="640080" y="365760"/>
+            <a:ext cx="10698480" cy="256032"/>
           </a:xfrm>
           <a:prstGeom prst="rect">
             <a:avLst/>
@@ -4642,7 +3957,43 @@
           <a:lstStyle/>
           <a:p>
             <a:pPr algn="l">
-              <a:defRPr sz="3400" b="1">
+              <a:defRPr sz="1000" b="0">
+                <a:solidFill>
+                  <a:srgbClr val="5A6472"/>
+                </a:solidFill>
+                <a:latin typeface="JetBrains Mono"/>
+              </a:defRPr>
+            </a:pPr>
+            <a:r>
+              <a:t>THE PROBLEM IS REAL</a:t>
+            </a:r>
+          </a:p>
+        </p:txBody>
+      </p:sp>
+      <p:sp>
+        <p:nvSpPr>
+          <p:cNvPr id="3" name="TextBox 2"/>
+          <p:cNvSpPr txBox="1"/>
+          <p:nvPr/>
+        </p:nvSpPr>
+        <p:spPr>
+          <a:xfrm>
+            <a:off x="640080" y="749808"/>
+            <a:ext cx="10698480" cy="658368"/>
+          </a:xfrm>
+          <a:prstGeom prst="rect">
+            <a:avLst/>
+          </a:prstGeom>
+          <a:noFill/>
+        </p:spPr>
+        <p:txBody>
+          <a:bodyPr wrap="square">
+            <a:spAutoFit/>
+          </a:bodyPr>
+          <a:lstStyle/>
+          <a:p>
+            <a:pPr algn="l">
+              <a:defRPr sz="3100" b="1">
                 <a:solidFill>
                   <a:srgbClr val="1F242E"/>
                 </a:solidFill>
@@ -4650,20 +4001,20 @@
               </a:defRPr>
             </a:pPr>
             <a:r>
-              <a:t>Three evidence checks become one verdict</a:t>
-            </a:r>
-          </a:p>
-        </p:txBody>
-      </p:sp>
-      <p:sp>
-        <p:nvSpPr>
-          <p:cNvPr id="3" name="Rectangle 2"/>
+              <a:t>Payment rails do not tell an agent whether the purchase was wise.</a:t>
+            </a:r>
+          </a:p>
+        </p:txBody>
+      </p:sp>
+      <p:sp>
+        <p:nvSpPr>
+          <p:cNvPr id="4" name="Rectangle 3"/>
           <p:cNvSpPr/>
           <p:nvPr/>
         </p:nvSpPr>
         <p:spPr>
           <a:xfrm>
-            <a:off x="640080" y="1115568"/>
+            <a:off x="640080" y="1536192"/>
             <a:ext cx="822960" cy="64008"/>
           </a:xfrm>
           <a:prstGeom prst="rect">
@@ -4700,7 +4051,7 @@
       </p:sp>
       <p:sp>
         <p:nvSpPr>
-          <p:cNvPr id="4" name="TextBox 3"/>
+          <p:cNvPr id="5" name="TextBox 4"/>
           <p:cNvSpPr txBox="1"/>
           <p:nvPr/>
         </p:nvSpPr>
@@ -4725,24 +4076,24 @@
                 <a:solidFill>
                   <a:srgbClr val="5A6472"/>
                 </a:solidFill>
-                <a:latin typeface="Courier New"/>
-              </a:defRPr>
-            </a:pPr>
-            <a:r>
-              <a:t>03 / 11</a:t>
-            </a:r>
-          </a:p>
-        </p:txBody>
-      </p:sp>
-      <p:sp>
-        <p:nvSpPr>
-          <p:cNvPr id="5" name="TextBox 4"/>
+                <a:latin typeface="JetBrains Mono"/>
+              </a:defRPr>
+            </a:pPr>
+            <a:r>
+              <a:t>03 / 10</a:t>
+            </a:r>
+          </a:p>
+        </p:txBody>
+      </p:sp>
+      <p:sp>
+        <p:nvSpPr>
+          <p:cNvPr id="6" name="TextBox 5"/>
           <p:cNvSpPr txBox="1"/>
           <p:nvPr/>
         </p:nvSpPr>
         <p:spPr>
           <a:xfrm>
-            <a:off x="640080" y="1508760"/>
+            <a:off x="640080" y="1783080"/>
             <a:ext cx="10698480" cy="502920"/>
           </a:xfrm>
           <a:prstGeom prst="rect">
@@ -4757,35 +4108,35 @@
           <a:lstStyle/>
           <a:p>
             <a:pPr algn="l">
-              <a:defRPr sz="2300" b="0">
+              <a:defRPr sz="1800" b="0">
                 <a:solidFill>
                   <a:srgbClr val="1F242E"/>
                 </a:solidFill>
-                <a:latin typeface="Arial"/>
-              </a:defRPr>
-            </a:pPr>
-            <a:r>
-              <a:t>The report keeps facts and judgment separate.</a:t>
-            </a:r>
-          </a:p>
-        </p:txBody>
-      </p:sp>
-      <p:sp>
-        <p:nvSpPr>
-          <p:cNvPr id="6" name="Rectangle 5"/>
+                <a:latin typeface="Inter"/>
+              </a:defRPr>
+            </a:pPr>
+            <a:r>
+              <a:t>x402 contributors ask for chargebacks and better payment intent. Cardano users already see imitation tokens and rug-pull warnings.</a:t>
+            </a:r>
+          </a:p>
+        </p:txBody>
+      </p:sp>
+      <p:sp>
+        <p:nvSpPr>
+          <p:cNvPr id="7" name="Rectangle 6"/>
           <p:cNvSpPr/>
           <p:nvPr/>
         </p:nvSpPr>
         <p:spPr>
           <a:xfrm>
-            <a:off x="640080" y="2331720"/>
-            <a:ext cx="3429000" cy="2331720"/>
+            <a:off x="640080" y="2514600"/>
+            <a:ext cx="3429000" cy="2468880"/>
           </a:xfrm>
           <a:prstGeom prst="rect">
             <a:avLst/>
           </a:prstGeom>
           <a:solidFill>
-            <a:srgbClr val="F8F9FB"/>
+            <a:srgbClr val="222731"/>
           </a:solidFill>
           <a:ln w="15240">
             <a:solidFill>
@@ -4814,58 +4165,51 @@
             <a:pPr algn="ctr">
               <a:defRPr sz="1700" b="1">
                 <a:solidFill>
-                  <a:srgbClr val="1F242E"/>
+                  <a:srgbClr val="F8F9FB"/>
                 </a:solidFill>
                 <a:latin typeface="Space Grotesk"/>
               </a:defRPr>
             </a:pPr>
             <a:r>
-              <a:t>01  Who controls it</a:t>
+              <a:t>x402 issue #508</a:t>
             </a:r>
           </a:p>
           <a:p>
             <a:pPr>
               <a:defRPr sz="1300">
                 <a:solidFill>
-                  <a:srgbClr val="1F242E"/>
-                </a:solidFill>
-                <a:latin typeface="Arial"/>
-              </a:defRPr>
-            </a:pPr>
-            <a:r>
-              <a:t>Mint policy open?</a:t>
+                  <a:srgbClr val="F8F9FB"/>
+                </a:solidFill>
+                <a:latin typeface="JetBrains Mono"/>
+              </a:defRPr>
+            </a:pPr>
+            <a:r>
+              <a:t>Phishing-like scams behind paid pages</a:t>
             </a:r>
             <a:br/>
-            <a:r>
-              <a:t>Admin key?</a:t>
-            </a:r>
             <a:br/>
             <a:r>
-              <a:t>First seen when?</a:t>
-            </a:r>
-            <a:br/>
-            <a:r>
-              <a:t>Known protocol?</a:t>
-            </a:r>
-          </a:p>
-        </p:txBody>
-      </p:sp>
-      <p:sp>
-        <p:nvSpPr>
-          <p:cNvPr id="7" name="Rectangle 6"/>
+              <a:t>github.com/x402-foundation/x402/issues/508</a:t>
+            </a:r>
+          </a:p>
+        </p:txBody>
+      </p:sp>
+      <p:sp>
+        <p:nvSpPr>
+          <p:cNvPr id="8" name="Rectangle 7"/>
           <p:cNvSpPr/>
           <p:nvPr/>
         </p:nvSpPr>
         <p:spPr>
           <a:xfrm>
-            <a:off x="4389120" y="2331720"/>
-            <a:ext cx="3429000" cy="2331720"/>
+            <a:off x="4389120" y="2514600"/>
+            <a:ext cx="3429000" cy="2468880"/>
           </a:xfrm>
           <a:prstGeom prst="rect">
             <a:avLst/>
           </a:prstGeom>
           <a:solidFill>
-            <a:srgbClr val="F8F9FB"/>
+            <a:srgbClr val="222731"/>
           </a:solidFill>
           <a:ln w="15240">
             <a:solidFill>
@@ -4894,48 +4238,45 @@
             <a:pPr algn="ctr">
               <a:defRPr sz="1700" b="1">
                 <a:solidFill>
-                  <a:srgbClr val="1F242E"/>
+                  <a:srgbClr val="F8F9FB"/>
                 </a:solidFill>
                 <a:latin typeface="Space Grotesk"/>
               </a:defRPr>
             </a:pPr>
             <a:r>
-              <a:t>02  Is the code safe</a:t>
+              <a:t>x402 issue #3500</a:t>
             </a:r>
           </a:p>
           <a:p>
             <a:pPr>
               <a:defRPr sz="1300">
                 <a:solidFill>
-                  <a:srgbClr val="1F242E"/>
-                </a:solidFill>
-                <a:latin typeface="Arial"/>
-              </a:defRPr>
-            </a:pPr>
-            <a:r>
-              <a:t>Script type and size</a:t>
+                  <a:srgbClr val="F8F9FB"/>
+                </a:solidFill>
+                <a:latin typeface="JetBrains Mono"/>
+              </a:defRPr>
+            </a:pPr>
+            <a:r>
+              <a:t>Agent paid $5.00 for a premium tier after asking for less</a:t>
             </a:r>
             <a:br/>
-            <a:r>
-              <a:t>Public Aiken source</a:t>
-            </a:r>
             <a:br/>
             <a:r>
-              <a:t>Exploit test before finding</a:t>
-            </a:r>
-          </a:p>
-        </p:txBody>
-      </p:sp>
-      <p:sp>
-        <p:nvSpPr>
-          <p:cNvPr id="8" name="Rectangle 7"/>
+              <a:t>github.com/x402-foundation/x402/issues/3500</a:t>
+            </a:r>
+          </a:p>
+        </p:txBody>
+      </p:sp>
+      <p:sp>
+        <p:nvSpPr>
+          <p:cNvPr id="9" name="Rectangle 8"/>
           <p:cNvSpPr/>
           <p:nvPr/>
         </p:nvSpPr>
         <p:spPr>
           <a:xfrm>
-            <a:off x="8138160" y="2331720"/>
-            <a:ext cx="3429000" cy="2331720"/>
+            <a:off x="8138160" y="2514600"/>
+            <a:ext cx="3429000" cy="2468880"/>
           </a:xfrm>
           <a:prstGeom prst="rect">
             <a:avLst/>
@@ -4976,7 +4317,7 @@
               </a:defRPr>
             </a:pPr>
             <a:r>
-              <a:t>03  Can you get in and out</a:t>
+              <a:t>38 / 100</a:t>
             </a:r>
           </a:p>
           <a:p>
@@ -4985,26 +4326,23 @@
                 <a:solidFill>
                   <a:srgbClr val="1F242E"/>
                 </a:solidFill>
-                <a:latin typeface="Arial"/>
-              </a:defRPr>
-            </a:pPr>
-            <a:r>
-              <a:t>Liquidity for the amount</a:t>
+                <a:latin typeface="Inter"/>
+              </a:defRPr>
+            </a:pPr>
+            <a:r>
+              <a:t>HN report: average fidelity across roughly 1,700 monitored services</a:t>
             </a:r>
             <a:br/>
-            <a:r>
-              <a:t>TVL, UTxOs, recent txs</a:t>
-            </a:r>
             <a:br/>
             <a:r>
-              <a:t>Settlement Desk when paying</a:t>
-            </a:r>
-          </a:p>
-        </p:txBody>
-      </p:sp>
-      <p:sp>
-        <p:nvSpPr>
-          <p:cNvPr id="9" name="TextBox 8"/>
+              <a:t>news.ycombinator.com/item?id=47158809</a:t>
+            </a:r>
+          </a:p>
+        </p:txBody>
+      </p:sp>
+      <p:sp>
+        <p:nvSpPr>
+          <p:cNvPr id="10" name="TextBox 9"/>
           <p:cNvSpPr txBox="1"/>
           <p:nvPr/>
         </p:nvSpPr>
@@ -5029,11 +4367,11 @@
                 <a:solidFill>
                   <a:srgbClr val="5A6472"/>
                 </a:solidFill>
-                <a:latin typeface="Courier New"/>
-              </a:defRPr>
-            </a:pPr>
-            <a:r>
-              <a:t>Cardano Risk Analyst  /  x402  /  Sokosumi  /  Masumi</a:t>
+                <a:latin typeface="JetBrains Mono"/>
+              </a:defRPr>
+            </a:pPr>
+            <a:r>
+              <a:t>Cardano Risk Desk  /  x402  /  Sokosumi  /  Masumi</a:t>
             </a:r>
           </a:p>
         </p:txBody>
@@ -5072,8 +4410,8 @@
         </p:nvSpPr>
         <p:spPr>
           <a:xfrm>
-            <a:off x="640080" y="411480"/>
-            <a:ext cx="10698480" cy="594360"/>
+            <a:off x="640080" y="365760"/>
+            <a:ext cx="10698480" cy="256032"/>
           </a:xfrm>
           <a:prstGeom prst="rect">
             <a:avLst/>
@@ -5087,7 +4425,43 @@
           <a:lstStyle/>
           <a:p>
             <a:pPr algn="l">
-              <a:defRPr sz="3400" b="1">
+              <a:defRPr sz="1000" b="0">
+                <a:solidFill>
+                  <a:srgbClr val="5A6472"/>
+                </a:solidFill>
+                <a:latin typeface="JetBrains Mono"/>
+              </a:defRPr>
+            </a:pPr>
+            <a:r>
+              <a:t>WHAT CAN GO WRONG ON CARDANO</a:t>
+            </a:r>
+          </a:p>
+        </p:txBody>
+      </p:sp>
+      <p:sp>
+        <p:nvSpPr>
+          <p:cNvPr id="3" name="TextBox 2"/>
+          <p:cNvSpPr txBox="1"/>
+          <p:nvPr/>
+        </p:nvSpPr>
+        <p:spPr>
+          <a:xfrm>
+            <a:off x="640080" y="749808"/>
+            <a:ext cx="10698480" cy="658368"/>
+          </a:xfrm>
+          <a:prstGeom prst="rect">
+            <a:avLst/>
+          </a:prstGeom>
+          <a:noFill/>
+        </p:spPr>
+        <p:txBody>
+          <a:bodyPr wrap="square">
+            <a:spAutoFit/>
+          </a:bodyPr>
+          <a:lstStyle/>
+          <a:p>
+            <a:pPr algn="l">
+              <a:defRPr sz="3100" b="1">
                 <a:solidFill>
                   <a:srgbClr val="1F242E"/>
                 </a:solidFill>
@@ -5095,20 +4469,20 @@
               </a:defRPr>
             </a:pPr>
             <a:r>
-              <a:t>Rules stay deterministic</a:t>
-            </a:r>
-          </a:p>
-        </p:txBody>
-      </p:sp>
-      <p:sp>
-        <p:nvSpPr>
-          <p:cNvPr id="3" name="Rectangle 2"/>
+              <a:t>The risk is in the asset, the address, and the script.</a:t>
+            </a:r>
+          </a:p>
+        </p:txBody>
+      </p:sp>
+      <p:sp>
+        <p:nvSpPr>
+          <p:cNvPr id="4" name="Rectangle 3"/>
           <p:cNvSpPr/>
           <p:nvPr/>
         </p:nvSpPr>
         <p:spPr>
           <a:xfrm>
-            <a:off x="640080" y="1115568"/>
+            <a:off x="640080" y="1536192"/>
             <a:ext cx="822960" cy="64008"/>
           </a:xfrm>
           <a:prstGeom prst="rect">
@@ -5145,7 +4519,7 @@
       </p:sp>
       <p:sp>
         <p:nvSpPr>
-          <p:cNvPr id="4" name="TextBox 3"/>
+          <p:cNvPr id="5" name="TextBox 4"/>
           <p:cNvSpPr txBox="1"/>
           <p:nvPr/>
         </p:nvSpPr>
@@ -5170,24 +4544,24 @@
                 <a:solidFill>
                   <a:srgbClr val="5A6472"/>
                 </a:solidFill>
-                <a:latin typeface="Courier New"/>
-              </a:defRPr>
-            </a:pPr>
-            <a:r>
-              <a:t>04 / 11</a:t>
-            </a:r>
-          </a:p>
-        </p:txBody>
-      </p:sp>
-      <p:sp>
-        <p:nvSpPr>
-          <p:cNvPr id="5" name="TextBox 4"/>
+                <a:latin typeface="JetBrains Mono"/>
+              </a:defRPr>
+            </a:pPr>
+            <a:r>
+              <a:t>04 / 10</a:t>
+            </a:r>
+          </a:p>
+        </p:txBody>
+      </p:sp>
+      <p:sp>
+        <p:nvSpPr>
+          <p:cNvPr id="6" name="TextBox 5"/>
           <p:cNvSpPr txBox="1"/>
           <p:nvPr/>
         </p:nvSpPr>
         <p:spPr>
           <a:xfrm>
-            <a:off x="640080" y="1508760"/>
+            <a:off x="640080" y="1783080"/>
             <a:ext cx="10698480" cy="502920"/>
           </a:xfrm>
           <a:prstGeom prst="rect">
@@ -5202,103 +4576,15 @@
           <a:lstStyle/>
           <a:p>
             <a:pPr algn="l">
-              <a:defRPr sz="2300" b="0">
+              <a:defRPr sz="1900" b="0">
                 <a:solidFill>
                   <a:srgbClr val="1F242E"/>
                 </a:solidFill>
-                <a:latin typeface="Arial"/>
-              </a:defRPr>
-            </a:pPr>
-            <a:r>
-              <a:t>The memo can be narrated. The verdict comes from explicit rules.</a:t>
-            </a:r>
-          </a:p>
-        </p:txBody>
-      </p:sp>
-      <p:sp>
-        <p:nvSpPr>
-          <p:cNvPr id="6" name="Rectangle 5"/>
-          <p:cNvSpPr/>
-          <p:nvPr/>
-        </p:nvSpPr>
-        <p:spPr>
-          <a:xfrm>
-            <a:off x="640080" y="2286000"/>
-            <a:ext cx="5212080" cy="2560320"/>
-          </a:xfrm>
-          <a:prstGeom prst="rect">
-            <a:avLst/>
-          </a:prstGeom>
-          <a:solidFill>
-            <a:srgbClr val="222731"/>
-          </a:solidFill>
-          <a:ln w="15240">
-            <a:solidFill>
-              <a:srgbClr val="C9D1DD"/>
-            </a:solidFill>
-          </a:ln>
-        </p:spPr>
-        <p:style>
-          <a:lnRef idx="1">
-            <a:schemeClr val="accent1"/>
-          </a:lnRef>
-          <a:fillRef idx="3">
-            <a:schemeClr val="accent1"/>
-          </a:fillRef>
-          <a:effectRef idx="2">
-            <a:schemeClr val="accent1"/>
-          </a:effectRef>
-          <a:fontRef idx="minor">
-            <a:schemeClr val="lt1"/>
-          </a:fontRef>
-        </p:style>
-        <p:txBody>
-          <a:bodyPr rtlCol="0" anchor="ctr" wrap="square"/>
-          <a:lstStyle/>
-          <a:p>
-            <a:pPr algn="ctr">
-              <a:defRPr sz="1700" b="1">
-                <a:solidFill>
-                  <a:srgbClr val="F8F9FB"/>
-                </a:solidFill>
-                <a:latin typeface="Space Grotesk"/>
-              </a:defRPr>
-            </a:pPr>
-            <a:r>
-              <a:t>Assessment shape</a:t>
-            </a:r>
-          </a:p>
-          <a:p>
-            <a:pPr>
-              <a:defRPr sz="1300">
-                <a:solidFill>
-                  <a:srgbClr val="F8F9FB"/>
-                </a:solidFill>
-                <a:latin typeface="Courier New"/>
-              </a:defRPr>
-            </a:pPr>
-            <a:r>
-              <a:t>decision</a:t>
-            </a:r>
-            <a:br/>
-            <a:r>
-              <a:t>blockingReasons[]</a:t>
-            </a:r>
-            <a:br/>
-            <a:r>
-              <a:t>conditions[]</a:t>
-            </a:r>
-            <a:br/>
-            <a:r>
-              <a:t>evidence[]</a:t>
-            </a:r>
-            <a:br/>
-            <a:r>
-              <a:t>subject</a:t>
-            </a:r>
-            <a:br/>
-            <a:r>
-              <a:t>checkedAt</a:t>
+                <a:latin typeface="Inter"/>
+              </a:defRPr>
+            </a:pPr>
+            <a:r>
+              <a:t>The report turns chain facts into a refusal before the agent pays.</a:t>
             </a:r>
           </a:p>
         </p:txBody>
@@ -5311,8 +4597,8 @@
         </p:nvSpPr>
         <p:spPr>
           <a:xfrm>
-            <a:off x="6217920" y="2286000"/>
-            <a:ext cx="5303520" cy="2560320"/>
+            <a:off x="640080" y="2651760"/>
+            <a:ext cx="3429000" cy="2331720"/>
           </a:xfrm>
           <a:prstGeom prst="rect">
             <a:avLst/>
@@ -5353,7 +4639,7 @@
               </a:defRPr>
             </a:pPr>
             <a:r>
-              <a:t>Rule examples</a:t>
+              <a:t>Open mint policy</a:t>
             </a:r>
           </a:p>
           <a:p>
@@ -5362,34 +4648,197 @@
                 <a:solidFill>
                   <a:srgbClr val="1F242E"/>
                 </a:solidFill>
-                <a:latin typeface="Arial"/>
-              </a:defRPr>
-            </a:pPr>
-            <a:r>
-              <a:t>mint policy open  →  blocking</a:t>
+                <a:latin typeface="Inter"/>
+              </a:defRPr>
+            </a:pPr>
+            <a:r>
+              <a:t>MIN.json</a:t>
             </a:r>
             <a:br/>
             <a:r>
-              <a:t>amount above caller cap  →  blocking</a:t>
+              <a:t>scriptType=native</a:t>
             </a:r>
             <a:br/>
             <a:r>
-              <a:t>new payTo  →  condition</a:t>
+              <a:t>requiredSigners=1</a:t>
             </a:r>
             <a:br/>
             <a:r>
-              <a:t>unknown protocol script  →  condition</a:t>
+              <a:t>mintOpen=true</a:t>
             </a:r>
             <a:br/>
-            <a:r>
-              <a:t>non-HTTPS resource  →  blocking</a:t>
-            </a:r>
-          </a:p>
-        </p:txBody>
-      </p:sp>
-      <p:sp>
-        <p:nvSpPr>
-          <p:cNvPr id="8" name="TextBox 7"/>
+            <a:br/>
+            <a:r>
+              <a:t>More supply can still be minted.</a:t>
+            </a:r>
+          </a:p>
+        </p:txBody>
+      </p:sp>
+      <p:sp>
+        <p:nvSpPr>
+          <p:cNvPr id="8" name="Rectangle 7"/>
+          <p:cNvSpPr/>
+          <p:nvPr/>
+        </p:nvSpPr>
+        <p:spPr>
+          <a:xfrm>
+            <a:off x="4389120" y="2651760"/>
+            <a:ext cx="3429000" cy="2331720"/>
+          </a:xfrm>
+          <a:prstGeom prst="rect">
+            <a:avLst/>
+          </a:prstGeom>
+          <a:solidFill>
+            <a:srgbClr val="F8F9FB"/>
+          </a:solidFill>
+          <a:ln w="15240">
+            <a:solidFill>
+              <a:srgbClr val="C9D1DD"/>
+            </a:solidFill>
+          </a:ln>
+        </p:spPr>
+        <p:style>
+          <a:lnRef idx="1">
+            <a:schemeClr val="accent1"/>
+          </a:lnRef>
+          <a:fillRef idx="3">
+            <a:schemeClr val="accent1"/>
+          </a:fillRef>
+          <a:effectRef idx="2">
+            <a:schemeClr val="accent1"/>
+          </a:effectRef>
+          <a:fontRef idx="minor">
+            <a:schemeClr val="lt1"/>
+          </a:fontRef>
+        </p:style>
+        <p:txBody>
+          <a:bodyPr rtlCol="0" anchor="ctr" wrap="square"/>
+          <a:lstStyle/>
+          <a:p>
+            <a:pPr algn="ctr">
+              <a:defRPr sz="1700" b="1">
+                <a:solidFill>
+                  <a:srgbClr val="1F242E"/>
+                </a:solidFill>
+                <a:latin typeface="Space Grotesk"/>
+              </a:defRPr>
+            </a:pPr>
+            <a:r>
+              <a:t>Fresh address</a:t>
+            </a:r>
+          </a:p>
+          <a:p>
+            <a:pPr>
+              <a:defRPr sz="1300">
+                <a:solidFill>
+                  <a:srgbClr val="1F242E"/>
+                </a:solidFill>
+                <a:latin typeface="Inter"/>
+              </a:defRPr>
+            </a:pPr>
+            <a:r>
+              <a:t>agent-demo/runs/1791341265898.json</a:t>
+            </a:r>
+            <a:br/>
+            <a:r>
+              <a:t>Seller B tx count: 1</a:t>
+            </a:r>
+            <a:br/>
+            <a:r>
+              <a:t>First seen: 2026-10-06</a:t>
+            </a:r>
+            <a:br/>
+            <a:br/>
+            <a:r>
+              <a:t>Newness becomes a condition.</a:t>
+            </a:r>
+          </a:p>
+        </p:txBody>
+      </p:sp>
+      <p:sp>
+        <p:nvSpPr>
+          <p:cNvPr id="9" name="Rectangle 8"/>
+          <p:cNvSpPr/>
+          <p:nvPr/>
+        </p:nvSpPr>
+        <p:spPr>
+          <a:xfrm>
+            <a:off x="8138160" y="2651760"/>
+            <a:ext cx="3429000" cy="2331720"/>
+          </a:xfrm>
+          <a:prstGeom prst="rect">
+            <a:avLst/>
+          </a:prstGeom>
+          <a:solidFill>
+            <a:srgbClr val="F8F9FB"/>
+          </a:solidFill>
+          <a:ln w="15240">
+            <a:solidFill>
+              <a:srgbClr val="C9D1DD"/>
+            </a:solidFill>
+          </a:ln>
+        </p:spPr>
+        <p:style>
+          <a:lnRef idx="1">
+            <a:schemeClr val="accent1"/>
+          </a:lnRef>
+          <a:fillRef idx="3">
+            <a:schemeClr val="accent1"/>
+          </a:fillRef>
+          <a:effectRef idx="2">
+            <a:schemeClr val="accent1"/>
+          </a:effectRef>
+          <a:fontRef idx="minor">
+            <a:schemeClr val="lt1"/>
+          </a:fontRef>
+        </p:style>
+        <p:txBody>
+          <a:bodyPr rtlCol="0" anchor="ctr" wrap="square"/>
+          <a:lstStyle/>
+          <a:p>
+            <a:pPr algn="ctr">
+              <a:defRPr sz="1700" b="1">
+                <a:solidFill>
+                  <a:srgbClr val="1F242E"/>
+                </a:solidFill>
+                <a:latin typeface="Space Grotesk"/>
+              </a:defRPr>
+            </a:pPr>
+            <a:r>
+              <a:t>Fake protocol script</a:t>
+            </a:r>
+          </a:p>
+          <a:p>
+            <a:pPr>
+              <a:defRPr sz="1300">
+                <a:solidFill>
+                  <a:srgbClr val="1F242E"/>
+                </a:solidFill>
+                <a:latin typeface="Inter"/>
+              </a:defRPr>
+            </a:pPr>
+            <a:r>
+              <a:t>MINt.json</a:t>
+            </a:r>
+            <a:br/>
+            <a:r>
+              <a:t>mint-open / high</a:t>
+            </a:r>
+            <a:br/>
+            <a:r>
+              <a:t>liquidity: 1766.6595103971542 ADA</a:t>
+            </a:r>
+            <a:br/>
+            <a:br/>
+            <a:r>
+              <a:t>A familiar name does not make an asset safe.</a:t>
+            </a:r>
+          </a:p>
+        </p:txBody>
+      </p:sp>
+      <p:sp>
+        <p:nvSpPr>
+          <p:cNvPr id="10" name="TextBox 9"/>
           <p:cNvSpPr txBox="1"/>
           <p:nvPr/>
         </p:nvSpPr>
@@ -5414,11 +4863,11 @@
                 <a:solidFill>
                   <a:srgbClr val="5A6472"/>
                 </a:solidFill>
-                <a:latin typeface="Courier New"/>
-              </a:defRPr>
-            </a:pPr>
-            <a:r>
-              <a:t>Cardano Risk Analyst  /  x402  /  Sokosumi  /  Masumi</a:t>
+                <a:latin typeface="JetBrains Mono"/>
+              </a:defRPr>
+            </a:pPr>
+            <a:r>
+              <a:t>Cardano Risk Desk  /  x402  /  Sokosumi  /  Masumi</a:t>
             </a:r>
           </a:p>
         </p:txBody>
@@ -5457,8 +4906,8 @@
         </p:nvSpPr>
         <p:spPr>
           <a:xfrm>
-            <a:off x="640080" y="411480"/>
-            <a:ext cx="10698480" cy="594360"/>
+            <a:off x="640080" y="365760"/>
+            <a:ext cx="10698480" cy="256032"/>
           </a:xfrm>
           <a:prstGeom prst="rect">
             <a:avLst/>
@@ -5472,7 +4921,43 @@
           <a:lstStyle/>
           <a:p>
             <a:pPr algn="l">
-              <a:defRPr sz="3400" b="1">
+              <a:defRPr sz="1000" b="0">
+                <a:solidFill>
+                  <a:srgbClr val="5A6472"/>
+                </a:solidFill>
+                <a:latin typeface="JetBrains Mono"/>
+              </a:defRPr>
+            </a:pPr>
+            <a:r>
+              <a:t>THE CHECK</a:t>
+            </a:r>
+          </a:p>
+        </p:txBody>
+      </p:sp>
+      <p:sp>
+        <p:nvSpPr>
+          <p:cNvPr id="3" name="TextBox 2"/>
+          <p:cNvSpPr txBox="1"/>
+          <p:nvPr/>
+        </p:nvSpPr>
+        <p:spPr>
+          <a:xfrm>
+            <a:off x="640080" y="749808"/>
+            <a:ext cx="10698480" cy="658368"/>
+          </a:xfrm>
+          <a:prstGeom prst="rect">
+            <a:avLst/>
+          </a:prstGeom>
+          <a:noFill/>
+        </p:spPr>
+        <p:txBody>
+          <a:bodyPr wrap="square">
+            <a:spAutoFit/>
+          </a:bodyPr>
+          <a:lstStyle/>
+          <a:p>
+            <a:pPr algn="l">
+              <a:defRPr sz="3100" b="1">
                 <a:solidFill>
                   <a:srgbClr val="1F242E"/>
                 </a:solidFill>
@@ -5480,20 +4965,20 @@
               </a:defRPr>
             </a:pPr>
             <a:r>
-              <a:t>A paid agent hires the Risk Desk</a:t>
-            </a:r>
-          </a:p>
-        </p:txBody>
-      </p:sp>
-      <p:sp>
-        <p:nvSpPr>
-          <p:cNvPr id="3" name="Rectangle 2"/>
+              <a:t>x402 becomes a payment gate, not just a payment rail.</a:t>
+            </a:r>
+          </a:p>
+        </p:txBody>
+      </p:sp>
+      <p:sp>
+        <p:nvSpPr>
+          <p:cNvPr id="4" name="Rectangle 3"/>
           <p:cNvSpPr/>
           <p:nvPr/>
         </p:nvSpPr>
         <p:spPr>
           <a:xfrm>
-            <a:off x="640080" y="1115568"/>
+            <a:off x="640080" y="1536192"/>
             <a:ext cx="822960" cy="64008"/>
           </a:xfrm>
           <a:prstGeom prst="rect">
@@ -5530,7 +5015,7 @@
       </p:sp>
       <p:sp>
         <p:nvSpPr>
-          <p:cNvPr id="4" name="TextBox 3"/>
+          <p:cNvPr id="5" name="TextBox 4"/>
           <p:cNvSpPr txBox="1"/>
           <p:nvPr/>
         </p:nvSpPr>
@@ -5555,47 +5040,11 @@
                 <a:solidFill>
                   <a:srgbClr val="5A6472"/>
                 </a:solidFill>
-                <a:latin typeface="Courier New"/>
-              </a:defRPr>
-            </a:pPr>
-            <a:r>
-              <a:t>05 / 11</a:t>
-            </a:r>
-          </a:p>
-        </p:txBody>
-      </p:sp>
-      <p:sp>
-        <p:nvSpPr>
-          <p:cNvPr id="5" name="TextBox 4"/>
-          <p:cNvSpPr txBox="1"/>
-          <p:nvPr/>
-        </p:nvSpPr>
-        <p:spPr>
-          <a:xfrm>
-            <a:off x="640080" y="1508760"/>
-            <a:ext cx="10698480" cy="502920"/>
-          </a:xfrm>
-          <a:prstGeom prst="rect">
-            <a:avLst/>
-          </a:prstGeom>
-          <a:noFill/>
-        </p:spPr>
-        <p:txBody>
-          <a:bodyPr wrap="square">
-            <a:spAutoFit/>
-          </a:bodyPr>
-          <a:lstStyle/>
-          <a:p>
-            <a:pPr algn="l">
-              <a:defRPr sz="2300" b="0">
-                <a:solidFill>
-                  <a:srgbClr val="1F242E"/>
-                </a:solidFill>
-                <a:latin typeface="Arial"/>
-              </a:defRPr>
-            </a:pPr>
-            <a:r>
-              <a:t>The same Coworker is available to agents, people, and Sokosumi Tasks.</a:t>
+                <a:latin typeface="JetBrains Mono"/>
+              </a:defRPr>
+            </a:pPr>
+            <a:r>
+              <a:t>05 / 10</a:t>
             </a:r>
           </a:p>
         </p:txBody>
@@ -5608,8 +5057,227 @@
         </p:nvSpPr>
         <p:spPr>
           <a:xfrm>
-            <a:off x="640080" y="2423160"/>
-            <a:ext cx="3383280" cy="1920240"/>
+            <a:off x="640080" y="2514600"/>
+            <a:ext cx="1920240" cy="2331720"/>
+          </a:xfrm>
+          <a:prstGeom prst="rect">
+            <a:avLst/>
+          </a:prstGeom>
+          <a:solidFill>
+            <a:srgbClr val="F8F9FB"/>
+          </a:solidFill>
+          <a:ln w="15240">
+            <a:solidFill>
+              <a:srgbClr val="C9D1DD"/>
+            </a:solidFill>
+          </a:ln>
+        </p:spPr>
+        <p:style>
+          <a:lnRef idx="1">
+            <a:schemeClr val="accent1"/>
+          </a:lnRef>
+          <a:fillRef idx="3">
+            <a:schemeClr val="accent1"/>
+          </a:fillRef>
+          <a:effectRef idx="2">
+            <a:schemeClr val="accent1"/>
+          </a:effectRef>
+          <a:fontRef idx="minor">
+            <a:schemeClr val="lt1"/>
+          </a:fontRef>
+        </p:style>
+        <p:txBody>
+          <a:bodyPr rtlCol="0" anchor="ctr" wrap="square"/>
+          <a:lstStyle/>
+          <a:p>
+            <a:pPr algn="ctr">
+              <a:defRPr sz="1700" b="1">
+                <a:solidFill>
+                  <a:srgbClr val="1F242E"/>
+                </a:solidFill>
+                <a:latin typeface="Space Grotesk"/>
+              </a:defRPr>
+            </a:pPr>
+            <a:r>
+              <a:t>402</a:t>
+            </a:r>
+          </a:p>
+          <a:p>
+            <a:pPr>
+              <a:defRPr sz="1300">
+                <a:solidFill>
+                  <a:srgbClr val="1F242E"/>
+                </a:solidFill>
+                <a:latin typeface="Inter"/>
+              </a:defRPr>
+            </a:pPr>
+            <a:r>
+              <a:t>Seller asks</a:t>
+            </a:r>
+            <a:br/>
+            <a:br/>
+            <a:r>
+              <a:t>asset · amount · payTo</a:t>
+            </a:r>
+          </a:p>
+        </p:txBody>
+      </p:sp>
+      <p:sp>
+        <p:nvSpPr>
+          <p:cNvPr id="7" name="Rectangle 6"/>
+          <p:cNvSpPr/>
+          <p:nvPr/>
+        </p:nvSpPr>
+        <p:spPr>
+          <a:xfrm>
+            <a:off x="2880360" y="2514600"/>
+            <a:ext cx="1920240" cy="2331720"/>
+          </a:xfrm>
+          <a:prstGeom prst="rect">
+            <a:avLst/>
+          </a:prstGeom>
+          <a:solidFill>
+            <a:srgbClr val="F8F9FB"/>
+          </a:solidFill>
+          <a:ln w="15240">
+            <a:solidFill>
+              <a:srgbClr val="C9D1DD"/>
+            </a:solidFill>
+          </a:ln>
+        </p:spPr>
+        <p:style>
+          <a:lnRef idx="1">
+            <a:schemeClr val="accent1"/>
+          </a:lnRef>
+          <a:fillRef idx="3">
+            <a:schemeClr val="accent1"/>
+          </a:fillRef>
+          <a:effectRef idx="2">
+            <a:schemeClr val="accent1"/>
+          </a:effectRef>
+          <a:fontRef idx="minor">
+            <a:schemeClr val="lt1"/>
+          </a:fontRef>
+        </p:style>
+        <p:txBody>
+          <a:bodyPr rtlCol="0" anchor="ctr" wrap="square"/>
+          <a:lstStyle/>
+          <a:p>
+            <a:pPr algn="ctr">
+              <a:defRPr sz="1700" b="1">
+                <a:solidFill>
+                  <a:srgbClr val="1F242E"/>
+                </a:solidFill>
+                <a:latin typeface="Space Grotesk"/>
+              </a:defRPr>
+            </a:pPr>
+            <a:r>
+              <a:t>01</a:t>
+            </a:r>
+          </a:p>
+          <a:p>
+            <a:pPr>
+              <a:defRPr sz="1300">
+                <a:solidFill>
+                  <a:srgbClr val="1F242E"/>
+                </a:solidFill>
+                <a:latin typeface="Inter"/>
+              </a:defRPr>
+            </a:pPr>
+            <a:r>
+              <a:t>Risk Desk</a:t>
+            </a:r>
+            <a:br/>
+            <a:br/>
+            <a:r>
+              <a:t>paid assessment</a:t>
+            </a:r>
+          </a:p>
+        </p:txBody>
+      </p:sp>
+      <p:sp>
+        <p:nvSpPr>
+          <p:cNvPr id="8" name="Rectangle 7"/>
+          <p:cNvSpPr/>
+          <p:nvPr/>
+        </p:nvSpPr>
+        <p:spPr>
+          <a:xfrm>
+            <a:off x="5120640" y="2514600"/>
+            <a:ext cx="1920240" cy="2331720"/>
+          </a:xfrm>
+          <a:prstGeom prst="rect">
+            <a:avLst/>
+          </a:prstGeom>
+          <a:solidFill>
+            <a:srgbClr val="F8F9FB"/>
+          </a:solidFill>
+          <a:ln w="15240">
+            <a:solidFill>
+              <a:srgbClr val="C9D1DD"/>
+            </a:solidFill>
+          </a:ln>
+        </p:spPr>
+        <p:style>
+          <a:lnRef idx="1">
+            <a:schemeClr val="accent1"/>
+          </a:lnRef>
+          <a:fillRef idx="3">
+            <a:schemeClr val="accent1"/>
+          </a:fillRef>
+          <a:effectRef idx="2">
+            <a:schemeClr val="accent1"/>
+          </a:effectRef>
+          <a:fontRef idx="minor">
+            <a:schemeClr val="lt1"/>
+          </a:fontRef>
+        </p:style>
+        <p:txBody>
+          <a:bodyPr rtlCol="0" anchor="ctr" wrap="square"/>
+          <a:lstStyle/>
+          <a:p>
+            <a:pPr algn="ctr">
+              <a:defRPr sz="1700" b="1">
+                <a:solidFill>
+                  <a:srgbClr val="1F242E"/>
+                </a:solidFill>
+                <a:latin typeface="Space Grotesk"/>
+              </a:defRPr>
+            </a:pPr>
+            <a:r>
+              <a:t>02</a:t>
+            </a:r>
+          </a:p>
+          <a:p>
+            <a:pPr>
+              <a:defRPr sz="1300">
+                <a:solidFill>
+                  <a:srgbClr val="1F242E"/>
+                </a:solidFill>
+                <a:latin typeface="Inter"/>
+              </a:defRPr>
+            </a:pPr>
+            <a:r>
+              <a:t>Evidence</a:t>
+            </a:r>
+            <a:br/>
+            <a:br/>
+            <a:r>
+              <a:t>policy · address · script</a:t>
+            </a:r>
+          </a:p>
+        </p:txBody>
+      </p:sp>
+      <p:sp>
+        <p:nvSpPr>
+          <p:cNvPr id="9" name="Rectangle 8"/>
+          <p:cNvSpPr/>
+          <p:nvPr/>
+        </p:nvSpPr>
+        <p:spPr>
+          <a:xfrm>
+            <a:off x="7360920" y="2514600"/>
+            <a:ext cx="1920240" cy="2331720"/>
           </a:xfrm>
           <a:prstGeom prst="rect">
             <a:avLst/>
@@ -5650,7 +5318,7 @@
               </a:defRPr>
             </a:pPr>
             <a:r>
-              <a:t>x402</a:t>
+              <a:t>03</a:t>
             </a:r>
           </a:p>
           <a:p>
@@ -5659,33 +5327,30 @@
                 <a:solidFill>
                   <a:srgbClr val="1F242E"/>
                 </a:solidFill>
-                <a:latin typeface="Arial"/>
-              </a:defRPr>
-            </a:pPr>
-            <a:r>
-              <a:t>Agent receives HTTP 402</a:t>
+                <a:latin typeface="Inter"/>
+              </a:defRPr>
+            </a:pPr>
+            <a:r>
+              <a:t>Decision</a:t>
             </a:r>
             <a:br/>
-            <a:r>
-              <a:t>Pays for a risk check</a:t>
-            </a:r>
             <a:br/>
             <a:r>
-              <a:t>Receives the assessment</a:t>
-            </a:r>
-          </a:p>
-        </p:txBody>
-      </p:sp>
-      <p:sp>
-        <p:nvSpPr>
-          <p:cNvPr id="7" name="Rectangle 6"/>
+              <a:t>interact or refuse</a:t>
+            </a:r>
+          </a:p>
+        </p:txBody>
+      </p:sp>
+      <p:sp>
+        <p:nvSpPr>
+          <p:cNvPr id="10" name="Rectangle 9"/>
           <p:cNvSpPr/>
           <p:nvPr/>
         </p:nvSpPr>
         <p:spPr>
           <a:xfrm>
-            <a:off x="4389120" y="2423160"/>
-            <a:ext cx="3383280" cy="1920240"/>
+            <a:off x="9601200" y="2514600"/>
+            <a:ext cx="1920240" cy="2331720"/>
           </a:xfrm>
           <a:prstGeom prst="rect">
             <a:avLst/>
@@ -5726,7 +5391,7 @@
               </a:defRPr>
             </a:pPr>
             <a:r>
-              <a:t>Human UI</a:t>
+              <a:t>04</a:t>
             </a:r>
           </a:p>
           <a:p>
@@ -5735,102 +5400,23 @@
                 <a:solidFill>
                   <a:srgbClr val="1F242E"/>
                 </a:solidFill>
-                <a:latin typeface="Arial"/>
-              </a:defRPr>
-            </a:pPr>
-            <a:r>
-              <a:t>Enter a token or script</a:t>
+                <a:latin typeface="Inter"/>
+              </a:defRPr>
+            </a:pPr>
+            <a:r>
+              <a:t>Payment</a:t>
             </a:r>
             <a:br/>
-            <a:r>
-              <a:t>Inspect cited evidence</a:t>
-            </a:r>
             <a:br/>
             <a:r>
-              <a:t>Choose the next action</a:t>
-            </a:r>
-          </a:p>
-        </p:txBody>
-      </p:sp>
-      <p:sp>
-        <p:nvSpPr>
-          <p:cNvPr id="8" name="Rectangle 7"/>
-          <p:cNvSpPr/>
-          <p:nvPr/>
-        </p:nvSpPr>
-        <p:spPr>
-          <a:xfrm>
-            <a:off x="8138160" y="2423160"/>
-            <a:ext cx="3383280" cy="1920240"/>
-          </a:xfrm>
-          <a:prstGeom prst="rect">
-            <a:avLst/>
-          </a:prstGeom>
-          <a:solidFill>
-            <a:srgbClr val="F8F9FB"/>
-          </a:solidFill>
-          <a:ln w="15240">
-            <a:solidFill>
-              <a:srgbClr val="C9D1DD"/>
-            </a:solidFill>
-          </a:ln>
-        </p:spPr>
-        <p:style>
-          <a:lnRef idx="1">
-            <a:schemeClr val="accent1"/>
-          </a:lnRef>
-          <a:fillRef idx="3">
-            <a:schemeClr val="accent1"/>
-          </a:fillRef>
-          <a:effectRef idx="2">
-            <a:schemeClr val="accent1"/>
-          </a:effectRef>
-          <a:fontRef idx="minor">
-            <a:schemeClr val="lt1"/>
-          </a:fontRef>
-        </p:style>
-        <p:txBody>
-          <a:bodyPr rtlCol="0" anchor="ctr" wrap="square"/>
-          <a:lstStyle/>
-          <a:p>
-            <a:pPr algn="ctr">
-              <a:defRPr sz="1700" b="1">
-                <a:solidFill>
-                  <a:srgbClr val="1F242E"/>
-                </a:solidFill>
-                <a:latin typeface="Space Grotesk"/>
-              </a:defRPr>
-            </a:pPr>
-            <a:r>
-              <a:t>Sokosumi</a:t>
-            </a:r>
-          </a:p>
-          <a:p>
-            <a:pPr>
-              <a:defRPr sz="1300">
-                <a:solidFill>
-                  <a:srgbClr val="1F242E"/>
-                </a:solidFill>
-                <a:latin typeface="Arial"/>
-              </a:defRPr>
-            </a:pPr>
-            <a:r>
-              <a:t>Hire Cardano Risk Analyst</a:t>
-            </a:r>
-            <a:br/>
-            <a:r>
-              <a:t>Task input is the target</a:t>
-            </a:r>
-            <a:br/>
-            <a:r>
-              <a:t>Masumi tracks the result</a:t>
-            </a:r>
-          </a:p>
-        </p:txBody>
-      </p:sp>
-      <p:sp>
-        <p:nvSpPr>
-          <p:cNvPr id="9" name="TextBox 8"/>
+              <a:t>sign only after check</a:t>
+            </a:r>
+          </a:p>
+        </p:txBody>
+      </p:sp>
+      <p:sp>
+        <p:nvSpPr>
+          <p:cNvPr id="11" name="TextBox 10"/>
           <p:cNvSpPr txBox="1"/>
           <p:nvPr/>
         </p:nvSpPr>
@@ -5855,11 +5441,11 @@
                 <a:solidFill>
                   <a:srgbClr val="5A6472"/>
                 </a:solidFill>
-                <a:latin typeface="Courier New"/>
-              </a:defRPr>
-            </a:pPr>
-            <a:r>
-              <a:t>Cardano Risk Analyst  /  x402  /  Sokosumi  /  Masumi</a:t>
+                <a:latin typeface="JetBrains Mono"/>
+              </a:defRPr>
+            </a:pPr>
+            <a:r>
+              <a:t>Cardano Risk Desk  /  x402  /  Sokosumi  /  Masumi</a:t>
             </a:r>
           </a:p>
         </p:txBody>
@@ -5898,8 +5484,8 @@
         </p:nvSpPr>
         <p:spPr>
           <a:xfrm>
-            <a:off x="640080" y="411480"/>
-            <a:ext cx="10698480" cy="594360"/>
+            <a:off x="640080" y="365760"/>
+            <a:ext cx="10698480" cy="256032"/>
           </a:xfrm>
           <a:prstGeom prst="rect">
             <a:avLst/>
@@ -5913,7 +5499,43 @@
           <a:lstStyle/>
           <a:p>
             <a:pPr algn="l">
-              <a:defRPr sz="3400" b="1">
+              <a:defRPr sz="1000" b="0">
+                <a:solidFill>
+                  <a:srgbClr val="5A6472"/>
+                </a:solidFill>
+                <a:latin typeface="JetBrains Mono"/>
+              </a:defRPr>
+            </a:pPr>
+            <a:r>
+              <a:t>PREPROD RUN / agent-demo/runs/1791341265898.json</a:t>
+            </a:r>
+          </a:p>
+        </p:txBody>
+      </p:sp>
+      <p:sp>
+        <p:nvSpPr>
+          <p:cNvPr id="3" name="TextBox 2"/>
+          <p:cNvSpPr txBox="1"/>
+          <p:nvPr/>
+        </p:nvSpPr>
+        <p:spPr>
+          <a:xfrm>
+            <a:off x="640080" y="749808"/>
+            <a:ext cx="10698480" cy="658368"/>
+          </a:xfrm>
+          <a:prstGeom prst="rect">
+            <a:avLst/>
+          </a:prstGeom>
+          <a:noFill/>
+        </p:spPr>
+        <p:txBody>
+          <a:bodyPr wrap="square">
+            <a:spAutoFit/>
+          </a:bodyPr>
+          <a:lstStyle/>
+          <a:p>
+            <a:pPr algn="l">
+              <a:defRPr sz="3100" b="1">
                 <a:solidFill>
                   <a:srgbClr val="1F242E"/>
                 </a:solidFill>
@@ -5921,20 +5543,20 @@
               </a:defRPr>
             </a:pPr>
             <a:r>
-              <a:t>The x402 flow checks the seller before payment</a:t>
-            </a:r>
-          </a:p>
-        </p:txBody>
-      </p:sp>
-      <p:sp>
-        <p:nvSpPr>
-          <p:cNvPr id="3" name="Rectangle 2"/>
+              <a:t>The check sent one seller payment and stopped the other.</a:t>
+            </a:r>
+          </a:p>
+        </p:txBody>
+      </p:sp>
+      <p:sp>
+        <p:nvSpPr>
+          <p:cNvPr id="4" name="Rectangle 3"/>
           <p:cNvSpPr/>
           <p:nvPr/>
         </p:nvSpPr>
         <p:spPr>
           <a:xfrm>
-            <a:off x="640080" y="1115568"/>
+            <a:off x="640080" y="1536192"/>
             <a:ext cx="822960" cy="64008"/>
           </a:xfrm>
           <a:prstGeom prst="rect">
@@ -5971,7 +5593,7 @@
       </p:sp>
       <p:sp>
         <p:nvSpPr>
-          <p:cNvPr id="4" name="TextBox 3"/>
+          <p:cNvPr id="5" name="TextBox 4"/>
           <p:cNvSpPr txBox="1"/>
           <p:nvPr/>
         </p:nvSpPr>
@@ -5996,25 +5618,138 @@
                 <a:solidFill>
                   <a:srgbClr val="5A6472"/>
                 </a:solidFill>
-                <a:latin typeface="Courier New"/>
-              </a:defRPr>
-            </a:pPr>
-            <a:r>
-              <a:t>06 / 11</a:t>
-            </a:r>
-          </a:p>
-        </p:txBody>
-      </p:sp>
-      <p:sp>
-        <p:nvSpPr>
-          <p:cNvPr id="5" name="Rectangle 4"/>
+                <a:latin typeface="JetBrains Mono"/>
+              </a:defRPr>
+            </a:pPr>
+            <a:r>
+              <a:t>06 / 10</a:t>
+            </a:r>
+          </a:p>
+        </p:txBody>
+      </p:sp>
+      <p:sp>
+        <p:nvSpPr>
+          <p:cNvPr id="6" name="TextBox 5"/>
+          <p:cNvSpPr txBox="1"/>
+          <p:nvPr/>
+        </p:nvSpPr>
+        <p:spPr>
+          <a:xfrm>
+            <a:off x="640080" y="1783080"/>
+            <a:ext cx="10698480" cy="457200"/>
+          </a:xfrm>
+          <a:prstGeom prst="rect">
+            <a:avLst/>
+          </a:prstGeom>
+          <a:noFill/>
+        </p:spPr>
+        <p:txBody>
+          <a:bodyPr wrap="square">
+            <a:spAutoFit/>
+          </a:bodyPr>
+          <a:lstStyle/>
+          <a:p>
+            <a:pPr algn="l">
+              <a:defRPr sz="1800" b="0">
+                <a:solidFill>
+                  <a:srgbClr val="1F242E"/>
+                </a:solidFill>
+                <a:latin typeface="Inter"/>
+              </a:defRPr>
+            </a:pPr>
+            <a:r>
+              <a:t>The same agent handled both 402 responses on Cardano preprod. Koios confirms every proof transaction.</a:t>
+            </a:r>
+          </a:p>
+        </p:txBody>
+      </p:sp>
+      <p:sp>
+        <p:nvSpPr>
+          <p:cNvPr id="7" name="Rectangle 6"/>
           <p:cNvSpPr/>
           <p:nvPr/>
         </p:nvSpPr>
         <p:spPr>
           <a:xfrm>
-            <a:off x="640080" y="2148840"/>
-            <a:ext cx="1920240" cy="2331720"/>
+            <a:off x="640080" y="2514600"/>
+            <a:ext cx="3429000" cy="2514600"/>
+          </a:xfrm>
+          <a:prstGeom prst="rect">
+            <a:avLst/>
+          </a:prstGeom>
+          <a:solidFill>
+            <a:srgbClr val="F8F9FB"/>
+          </a:solidFill>
+          <a:ln w="15240">
+            <a:solidFill>
+              <a:srgbClr val="4678E8"/>
+            </a:solidFill>
+          </a:ln>
+        </p:spPr>
+        <p:style>
+          <a:lnRef idx="1">
+            <a:schemeClr val="accent1"/>
+          </a:lnRef>
+          <a:fillRef idx="3">
+            <a:schemeClr val="accent1"/>
+          </a:fillRef>
+          <a:effectRef idx="2">
+            <a:schemeClr val="accent1"/>
+          </a:effectRef>
+          <a:fontRef idx="minor">
+            <a:schemeClr val="lt1"/>
+          </a:fontRef>
+        </p:style>
+        <p:txBody>
+          <a:bodyPr rtlCol="0" anchor="ctr" wrap="square"/>
+          <a:lstStyle/>
+          <a:p>
+            <a:pPr algn="ctr">
+              <a:defRPr sz="1700" b="1">
+                <a:solidFill>
+                  <a:srgbClr val="4678E8"/>
+                </a:solidFill>
+                <a:latin typeface="Space Grotesk"/>
+              </a:defRPr>
+            </a:pPr>
+            <a:r>
+              <a:t>Seller A / INTERACT</a:t>
+            </a:r>
+          </a:p>
+          <a:p>
+            <a:pPr>
+              <a:defRPr sz="1300">
+                <a:solidFill>
+                  <a:srgbClr val="1F242E"/>
+                </a:solidFill>
+                <a:latin typeface="Inter"/>
+              </a:defRPr>
+            </a:pPr>
+            <a:r>
+              <a:t>Quote: 2,000,000 lovelace</a:t>
+            </a:r>
+            <a:br/>
+            <a:br/>
+            <a:r>
+              <a:t>Risk check 91ae89f5...</a:t>
+            </a:r>
+            <a:br/>
+            <a:r>
+              <a:t>Seller paid 6f514c89...</a:t>
+            </a:r>
+          </a:p>
+        </p:txBody>
+      </p:sp>
+      <p:sp>
+        <p:nvSpPr>
+          <p:cNvPr id="8" name="Rectangle 7"/>
+          <p:cNvSpPr/>
+          <p:nvPr/>
+        </p:nvSpPr>
+        <p:spPr>
+          <a:xfrm>
+            <a:off x="4389120" y="2514600"/>
+            <a:ext cx="3429000" cy="2514600"/>
           </a:xfrm>
           <a:prstGeom prst="rect">
             <a:avLst/>
@@ -6055,7 +5790,7 @@
               </a:defRPr>
             </a:pPr>
             <a:r>
-              <a:t>402</a:t>
+              <a:t>Seller B / DO_NOT_INTERACT</a:t>
             </a:r>
           </a:p>
           <a:p>
@@ -6064,36 +5799,44 @@
                 <a:solidFill>
                   <a:srgbClr val="1F242E"/>
                 </a:solidFill>
-                <a:latin typeface="Arial"/>
-              </a:defRPr>
-            </a:pPr>
-            <a:r>
-              <a:t>Seller asks</a:t>
+                <a:latin typeface="Inter"/>
+              </a:defRPr>
+            </a:pPr>
+            <a:r>
+              <a:t>Quote: 5 custom-token units</a:t>
             </a:r>
             <a:br/>
             <a:br/>
             <a:r>
-              <a:t>asset, amount, payTo, resource</a:t>
-            </a:r>
-          </a:p>
-        </p:txBody>
-      </p:sp>
-      <p:sp>
-        <p:nvSpPr>
-          <p:cNvPr id="6" name="Rectangle 5"/>
+              <a:t>Risk check c063f45b...</a:t>
+            </a:r>
+            <a:br/>
+            <a:r>
+              <a:t>Reason: asset-mint-open</a:t>
+            </a:r>
+            <a:br/>
+            <a:r>
+              <a:t>Seller payment was not sent</a:t>
+            </a:r>
+          </a:p>
+        </p:txBody>
+      </p:sp>
+      <p:sp>
+        <p:nvSpPr>
+          <p:cNvPr id="9" name="Rectangle 8"/>
           <p:cNvSpPr/>
           <p:nvPr/>
         </p:nvSpPr>
         <p:spPr>
           <a:xfrm>
-            <a:off x="2880360" y="2148840"/>
-            <a:ext cx="1920240" cy="2331720"/>
+            <a:off x="8138160" y="2514600"/>
+            <a:ext cx="3429000" cy="2514600"/>
           </a:xfrm>
           <a:prstGeom prst="rect">
             <a:avLst/>
           </a:prstGeom>
           <a:solidFill>
-            <a:srgbClr val="F8F9FB"/>
+            <a:srgbClr val="222731"/>
           </a:solidFill>
           <a:ln w="15240">
             <a:solidFill>
@@ -6122,250 +5865,31 @@
             <a:pPr algn="ctr">
               <a:defRPr sz="1700" b="1">
                 <a:solidFill>
-                  <a:srgbClr val="1F242E"/>
+                  <a:srgbClr val="F8F9FB"/>
                 </a:solidFill>
                 <a:latin typeface="Space Grotesk"/>
               </a:defRPr>
             </a:pPr>
             <a:r>
-              <a:t>01</a:t>
+              <a:t>The branch</a:t>
             </a:r>
           </a:p>
           <a:p>
             <a:pPr>
               <a:defRPr sz="1300">
                 <a:solidFill>
-                  <a:srgbClr val="1F242E"/>
-                </a:solidFill>
-                <a:latin typeface="Arial"/>
-              </a:defRPr>
-            </a:pPr>
-            <a:r>
-              <a:t>Risk check</a:t>
+                  <a:srgbClr val="F8F9FB"/>
+                </a:solidFill>
+                <a:latin typeface="JetBrains Mono"/>
+              </a:defRPr>
+            </a:pPr>
+            <a:r>
+              <a:t>INTERACT  →  pay seller</a:t>
             </a:r>
             <a:br/>
             <a:br/>
             <a:r>
-              <a:t>x402 pays the Risk Desk</a:t>
-            </a:r>
-          </a:p>
-        </p:txBody>
-      </p:sp>
-      <p:sp>
-        <p:nvSpPr>
-          <p:cNvPr id="7" name="Rectangle 6"/>
-          <p:cNvSpPr/>
-          <p:nvPr/>
-        </p:nvSpPr>
-        <p:spPr>
-          <a:xfrm>
-            <a:off x="5120640" y="2148840"/>
-            <a:ext cx="1920240" cy="2331720"/>
-          </a:xfrm>
-          <a:prstGeom prst="rect">
-            <a:avLst/>
-          </a:prstGeom>
-          <a:solidFill>
-            <a:srgbClr val="F8F9FB"/>
-          </a:solidFill>
-          <a:ln w="15240">
-            <a:solidFill>
-              <a:srgbClr val="4678E8"/>
-            </a:solidFill>
-          </a:ln>
-        </p:spPr>
-        <p:style>
-          <a:lnRef idx="1">
-            <a:schemeClr val="accent1"/>
-          </a:lnRef>
-          <a:fillRef idx="3">
-            <a:schemeClr val="accent1"/>
-          </a:fillRef>
-          <a:effectRef idx="2">
-            <a:schemeClr val="accent1"/>
-          </a:effectRef>
-          <a:fontRef idx="minor">
-            <a:schemeClr val="lt1"/>
-          </a:fontRef>
-        </p:style>
-        <p:txBody>
-          <a:bodyPr rtlCol="0" anchor="ctr" wrap="square"/>
-          <a:lstStyle/>
-          <a:p>
-            <a:pPr algn="ctr">
-              <a:defRPr sz="1700" b="1">
-                <a:solidFill>
-                  <a:srgbClr val="4678E8"/>
-                </a:solidFill>
-                <a:latin typeface="Space Grotesk"/>
-              </a:defRPr>
-            </a:pPr>
-            <a:r>
-              <a:t>02</a:t>
-            </a:r>
-          </a:p>
-          <a:p>
-            <a:pPr>
-              <a:defRPr sz="1300">
-                <a:solidFill>
-                  <a:srgbClr val="1F242E"/>
-                </a:solidFill>
-                <a:latin typeface="Arial"/>
-              </a:defRPr>
-            </a:pPr>
-            <a:r>
-              <a:t>Evidence</a:t>
-            </a:r>
-            <a:br/>
-            <a:br/>
-            <a:r>
-              <a:t>counterparty, asset, request</a:t>
-            </a:r>
-          </a:p>
-        </p:txBody>
-      </p:sp>
-      <p:sp>
-        <p:nvSpPr>
-          <p:cNvPr id="8" name="Rectangle 7"/>
-          <p:cNvSpPr/>
-          <p:nvPr/>
-        </p:nvSpPr>
-        <p:spPr>
-          <a:xfrm>
-            <a:off x="7360920" y="2148840"/>
-            <a:ext cx="1920240" cy="2331720"/>
-          </a:xfrm>
-          <a:prstGeom prst="rect">
-            <a:avLst/>
-          </a:prstGeom>
-          <a:solidFill>
-            <a:srgbClr val="F8F9FB"/>
-          </a:solidFill>
-          <a:ln w="15240">
-            <a:solidFill>
-              <a:srgbClr val="C9D1DD"/>
-            </a:solidFill>
-          </a:ln>
-        </p:spPr>
-        <p:style>
-          <a:lnRef idx="1">
-            <a:schemeClr val="accent1"/>
-          </a:lnRef>
-          <a:fillRef idx="3">
-            <a:schemeClr val="accent1"/>
-          </a:fillRef>
-          <a:effectRef idx="2">
-            <a:schemeClr val="accent1"/>
-          </a:effectRef>
-          <a:fontRef idx="minor">
-            <a:schemeClr val="lt1"/>
-          </a:fontRef>
-        </p:style>
-        <p:txBody>
-          <a:bodyPr rtlCol="0" anchor="ctr" wrap="square"/>
-          <a:lstStyle/>
-          <a:p>
-            <a:pPr algn="ctr">
-              <a:defRPr sz="1700" b="1">
-                <a:solidFill>
-                  <a:srgbClr val="1F242E"/>
-                </a:solidFill>
-                <a:latin typeface="Space Grotesk"/>
-              </a:defRPr>
-            </a:pPr>
-            <a:r>
-              <a:t>03</a:t>
-            </a:r>
-          </a:p>
-          <a:p>
-            <a:pPr>
-              <a:defRPr sz="1300">
-                <a:solidFill>
-                  <a:srgbClr val="1F242E"/>
-                </a:solidFill>
-                <a:latin typeface="Arial"/>
-              </a:defRPr>
-            </a:pPr>
-            <a:r>
-              <a:t>Decision</a:t>
-            </a:r>
-            <a:br/>
-            <a:br/>
-            <a:r>
-              <a:t>stop or continue</a:t>
-            </a:r>
-          </a:p>
-        </p:txBody>
-      </p:sp>
-      <p:sp>
-        <p:nvSpPr>
-          <p:cNvPr id="9" name="Rectangle 8"/>
-          <p:cNvSpPr/>
-          <p:nvPr/>
-        </p:nvSpPr>
-        <p:spPr>
-          <a:xfrm>
-            <a:off x="9601200" y="2148840"/>
-            <a:ext cx="1920240" cy="2331720"/>
-          </a:xfrm>
-          <a:prstGeom prst="rect">
-            <a:avLst/>
-          </a:prstGeom>
-          <a:solidFill>
-            <a:srgbClr val="F8F9FB"/>
-          </a:solidFill>
-          <a:ln w="15240">
-            <a:solidFill>
-              <a:srgbClr val="C9D1DD"/>
-            </a:solidFill>
-          </a:ln>
-        </p:spPr>
-        <p:style>
-          <a:lnRef idx="1">
-            <a:schemeClr val="accent1"/>
-          </a:lnRef>
-          <a:fillRef idx="3">
-            <a:schemeClr val="accent1"/>
-          </a:fillRef>
-          <a:effectRef idx="2">
-            <a:schemeClr val="accent1"/>
-          </a:effectRef>
-          <a:fontRef idx="minor">
-            <a:schemeClr val="lt1"/>
-          </a:fontRef>
-        </p:style>
-        <p:txBody>
-          <a:bodyPr rtlCol="0" anchor="ctr" wrap="square"/>
-          <a:lstStyle/>
-          <a:p>
-            <a:pPr algn="ctr">
-              <a:defRPr sz="1700" b="1">
-                <a:solidFill>
-                  <a:srgbClr val="1F242E"/>
-                </a:solidFill>
-                <a:latin typeface="Space Grotesk"/>
-              </a:defRPr>
-            </a:pPr>
-            <a:r>
-              <a:t>04</a:t>
-            </a:r>
-          </a:p>
-          <a:p>
-            <a:pPr>
-              <a:defRPr sz="1300">
-                <a:solidFill>
-                  <a:srgbClr val="1F242E"/>
-                </a:solidFill>
-                <a:latin typeface="Arial"/>
-              </a:defRPr>
-            </a:pPr>
-            <a:r>
-              <a:t>Payment</a:t>
-            </a:r>
-            <a:br/>
-            <a:br/>
-            <a:r>
-              <a:t>only after the verdict</a:t>
+              <a:t>DO_NOT_INTERACT  →  refuse seller</a:t>
             </a:r>
           </a:p>
         </p:txBody>
@@ -6378,8 +5902,8 @@
         </p:nvSpPr>
         <p:spPr>
           <a:xfrm>
-            <a:off x="640080" y="5074920"/>
-            <a:ext cx="10698480" cy="411480"/>
+            <a:off x="640080" y="6355080"/>
+            <a:ext cx="8686800" cy="228600"/>
           </a:xfrm>
           <a:prstGeom prst="rect">
             <a:avLst/>
@@ -6392,52 +5916,16 @@
           </a:bodyPr>
           <a:lstStyle/>
           <a:p>
-            <a:pPr algn="ctr">
-              <a:defRPr sz="1800" b="1">
-                <a:solidFill>
-                  <a:srgbClr val="1F242E"/>
-                </a:solidFill>
-                <a:latin typeface="Arial"/>
-              </a:defRPr>
-            </a:pPr>
-            <a:r>
-              <a:t>Risk Desk is the economic pause between receiving a payment request and signing it.</a:t>
-            </a:r>
-          </a:p>
-        </p:txBody>
-      </p:sp>
-      <p:sp>
-        <p:nvSpPr>
-          <p:cNvPr id="11" name="TextBox 10"/>
-          <p:cNvSpPr txBox="1"/>
-          <p:nvPr/>
-        </p:nvSpPr>
-        <p:spPr>
-          <a:xfrm>
-            <a:off x="640080" y="6355080"/>
-            <a:ext cx="8686800" cy="228600"/>
-          </a:xfrm>
-          <a:prstGeom prst="rect">
-            <a:avLst/>
-          </a:prstGeom>
-          <a:noFill/>
-        </p:spPr>
-        <p:txBody>
-          <a:bodyPr wrap="square">
-            <a:spAutoFit/>
-          </a:bodyPr>
-          <a:lstStyle/>
-          <a:p>
             <a:pPr algn="l">
               <a:defRPr sz="1000" b="0">
                 <a:solidFill>
                   <a:srgbClr val="5A6472"/>
                 </a:solidFill>
-                <a:latin typeface="Courier New"/>
-              </a:defRPr>
-            </a:pPr>
-            <a:r>
-              <a:t>Cardano Risk Analyst  /  x402  /  Sokosumi  /  Masumi</a:t>
+                <a:latin typeface="JetBrains Mono"/>
+              </a:defRPr>
+            </a:pPr>
+            <a:r>
+              <a:t>Cardano Risk Desk  /  x402  /  Sokosumi  /  Masumi</a:t>
             </a:r>
           </a:p>
         </p:txBody>
@@ -6476,8 +5964,8 @@
         </p:nvSpPr>
         <p:spPr>
           <a:xfrm>
-            <a:off x="640080" y="411480"/>
-            <a:ext cx="10698480" cy="594360"/>
+            <a:off x="640080" y="365760"/>
+            <a:ext cx="10698480" cy="256032"/>
           </a:xfrm>
           <a:prstGeom prst="rect">
             <a:avLst/>
@@ -6491,7 +5979,43 @@
           <a:lstStyle/>
           <a:p>
             <a:pPr algn="l">
-              <a:defRPr sz="3400" b="1">
+              <a:defRPr sz="1000" b="0">
+                <a:solidFill>
+                  <a:srgbClr val="5A6472"/>
+                </a:solidFill>
+                <a:latin typeface="JetBrains Mono"/>
+              </a:defRPr>
+            </a:pPr>
+            <a:r>
+              <a:t>PRODUCTION PROOF / web/lib/x402/LIVE-PROOF.json</a:t>
+            </a:r>
+          </a:p>
+        </p:txBody>
+      </p:sp>
+      <p:sp>
+        <p:nvSpPr>
+          <p:cNvPr id="3" name="TextBox 2"/>
+          <p:cNvSpPr txBox="1"/>
+          <p:nvPr/>
+        </p:nvSpPr>
+        <p:spPr>
+          <a:xfrm>
+            <a:off x="640080" y="749808"/>
+            <a:ext cx="10698480" cy="658368"/>
+          </a:xfrm>
+          <a:prstGeom prst="rect">
+            <a:avLst/>
+          </a:prstGeom>
+          <a:noFill/>
+        </p:spPr>
+        <p:txBody>
+          <a:bodyPr wrap="square">
+            <a:spAutoFit/>
+          </a:bodyPr>
+          <a:lstStyle/>
+          <a:p>
+            <a:pPr algn="l">
+              <a:defRPr sz="3100" b="1">
                 <a:solidFill>
                   <a:srgbClr val="1F242E"/>
                 </a:solidFill>
@@ -6499,20 +6023,20 @@
               </a:defRPr>
             </a:pPr>
             <a:r>
-              <a:t>Mainnet evidence: MIN</a:t>
-            </a:r>
-          </a:p>
-        </p:txBody>
-      </p:sp>
-      <p:sp>
-        <p:nvSpPr>
-          <p:cNvPr id="3" name="Rectangle 2"/>
+              <a:t>The live endpoint settles once and rejects a replay.</a:t>
+            </a:r>
+          </a:p>
+        </p:txBody>
+      </p:sp>
+      <p:sp>
+        <p:nvSpPr>
+          <p:cNvPr id="4" name="Rectangle 3"/>
           <p:cNvSpPr/>
           <p:nvPr/>
         </p:nvSpPr>
         <p:spPr>
           <a:xfrm>
-            <a:off x="640080" y="1115568"/>
+            <a:off x="640080" y="1536192"/>
             <a:ext cx="822960" cy="64008"/>
           </a:xfrm>
           <a:prstGeom prst="rect">
@@ -6549,7 +6073,7 @@
       </p:sp>
       <p:sp>
         <p:nvSpPr>
-          <p:cNvPr id="4" name="TextBox 3"/>
+          <p:cNvPr id="5" name="TextBox 4"/>
           <p:cNvSpPr txBox="1"/>
           <p:nvPr/>
         </p:nvSpPr>
@@ -6574,25 +6098,25 @@
                 <a:solidFill>
                   <a:srgbClr val="5A6472"/>
                 </a:solidFill>
-                <a:latin typeface="Courier New"/>
-              </a:defRPr>
-            </a:pPr>
-            <a:r>
-              <a:t>07 / 11</a:t>
-            </a:r>
-          </a:p>
-        </p:txBody>
-      </p:sp>
-      <p:sp>
-        <p:nvSpPr>
-          <p:cNvPr id="5" name="TextBox 4"/>
+                <a:latin typeface="JetBrains Mono"/>
+              </a:defRPr>
+            </a:pPr>
+            <a:r>
+              <a:t>07 / 10</a:t>
+            </a:r>
+          </a:p>
+        </p:txBody>
+      </p:sp>
+      <p:sp>
+        <p:nvSpPr>
+          <p:cNvPr id="6" name="TextBox 5"/>
           <p:cNvSpPr txBox="1"/>
           <p:nvPr/>
         </p:nvSpPr>
         <p:spPr>
           <a:xfrm>
-            <a:off x="640080" y="1508760"/>
-            <a:ext cx="10698480" cy="502920"/>
+            <a:off x="640080" y="1783080"/>
+            <a:ext cx="10698480" cy="457200"/>
           </a:xfrm>
           <a:prstGeom prst="rect">
             <a:avLst/>
@@ -6606,29 +6130,29 @@
           <a:lstStyle/>
           <a:p>
             <a:pPr algn="l">
-              <a:defRPr sz="2300" b="0">
+              <a:defRPr sz="1800" b="0">
                 <a:solidFill>
                   <a:srgbClr val="1F242E"/>
                 </a:solidFill>
-                <a:latin typeface="Arial"/>
-              </a:defRPr>
-            </a:pPr>
-            <a:r>
-              <a:t>The stored report says DO NOT INTERACT because the native mint policy remains open.</a:t>
-            </a:r>
-          </a:p>
-        </p:txBody>
-      </p:sp>
-      <p:sp>
-        <p:nvSpPr>
-          <p:cNvPr id="6" name="Rectangle 5"/>
+                <a:latin typeface="Inter"/>
+              </a:defRPr>
+            </a:pPr>
+            <a:r>
+              <a:t>The production x402 call returned INTERACT. The same payment presented again returned HTTP 409.</a:t>
+            </a:r>
+          </a:p>
+        </p:txBody>
+      </p:sp>
+      <p:sp>
+        <p:nvSpPr>
+          <p:cNvPr id="7" name="Rectangle 6"/>
           <p:cNvSpPr/>
           <p:nvPr/>
         </p:nvSpPr>
         <p:spPr>
           <a:xfrm>
-            <a:off x="640080" y="2240280"/>
-            <a:ext cx="5166360" cy="2651760"/>
+            <a:off x="640080" y="2606040"/>
+            <a:ext cx="5166360" cy="2514600"/>
           </a:xfrm>
           <a:prstGeom prst="rect">
             <a:avLst/>
@@ -6669,7 +6193,7 @@
               </a:defRPr>
             </a:pPr>
             <a:r>
-              <a:t>DO NOT INTERACT</a:t>
+              <a:t>Cardano preprod</a:t>
             </a:r>
           </a:p>
           <a:p>
@@ -6678,41 +6202,38 @@
                 <a:solidFill>
                   <a:srgbClr val="1F242E"/>
                 </a:solidFill>
-                <a:latin typeface="Arial"/>
-              </a:defRPr>
-            </a:pPr>
-            <a:r>
-              <a:t>MIN</a:t>
+                <a:latin typeface="Inter"/>
+              </a:defRPr>
+            </a:pPr>
+            <a:r>
+              <a:t>Endpoint: cardano-risk-coworker.vercel.app/api/x402/risk-check</a:t>
             </a:r>
             <a:br/>
-            <a:r>
-              <a:t>Native policy</a:t>
-            </a:r>
             <a:br/>
             <a:r>
-              <a:t>Required signers: 1</a:t>
+              <a:t>Paid: HTTP 200</a:t>
             </a:r>
             <a:br/>
             <a:r>
-              <a:t>Mint policy: open</a:t>
+              <a:t>Decision: INTERACT</a:t>
             </a:r>
             <a:br/>
             <a:r>
-              <a:t>Finding: mint-open / high</a:t>
-            </a:r>
-          </a:p>
-        </p:txBody>
-      </p:sp>
-      <p:sp>
-        <p:nvSpPr>
-          <p:cNvPr id="7" name="Rectangle 6"/>
+              <a:t>Koios confirmations: 1</a:t>
+            </a:r>
+          </a:p>
+        </p:txBody>
+      </p:sp>
+      <p:sp>
+        <p:nvSpPr>
+          <p:cNvPr id="8" name="Rectangle 7"/>
           <p:cNvSpPr/>
           <p:nvPr/>
         </p:nvSpPr>
         <p:spPr>
           <a:xfrm>
-            <a:off x="6172200" y="2240280"/>
-            <a:ext cx="5349240" cy="2651760"/>
+            <a:off x="6172200" y="2606040"/>
+            <a:ext cx="5349240" cy="2514600"/>
           </a:xfrm>
           <a:prstGeom prst="rect">
             <a:avLst/>
@@ -6753,7 +6274,7 @@
               </a:defRPr>
             </a:pPr>
             <a:r>
-              <a:t>Source calls</a:t>
+              <a:t>Replay protection</a:t>
             </a:r>
           </a:p>
           <a:p>
@@ -6762,31 +6283,28 @@
                 <a:solidFill>
                   <a:srgbClr val="F8F9FB"/>
                 </a:solidFill>
-                <a:latin typeface="Courier New"/>
-              </a:defRPr>
-            </a:pPr>
-            <a:r>
-              <a:t>asset_info_29d222ce...</a:t>
-            </a:r>
-            <a:br/>
-            <a:r>
-              <a:t>registry_29d222ce...</a:t>
-            </a:r>
-            <a:br/>
-            <a:r>
-              <a:t>script_info_29d222ce...</a:t>
+                <a:latin typeface="JetBrains Mono"/>
+              </a:defRPr>
+            </a:pPr>
+            <a:r>
+              <a:t>Same payment</a:t>
             </a:r>
             <a:br/>
             <a:br/>
             <a:r>
-              <a:t>Report: engine/reports/MIN.json</a:t>
-            </a:r>
-          </a:p>
-        </p:txBody>
-      </p:sp>
-      <p:sp>
-        <p:nvSpPr>
-          <p:cNvPr id="8" name="TextBox 7"/>
+              <a:t>HTTP 409</a:t>
+            </a:r>
+            <a:br/>
+            <a:br/>
+            <a:r>
+              <a:t>66d28ffbb319d191ee62bc0833af6af031c463604cba5b2121f007ce705dd5ba</a:t>
+            </a:r>
+          </a:p>
+        </p:txBody>
+      </p:sp>
+      <p:sp>
+        <p:nvSpPr>
+          <p:cNvPr id="9" name="TextBox 8"/>
           <p:cNvSpPr txBox="1"/>
           <p:nvPr/>
         </p:nvSpPr>
@@ -6811,11 +6329,11 @@
                 <a:solidFill>
                   <a:srgbClr val="5A6472"/>
                 </a:solidFill>
-                <a:latin typeface="Courier New"/>
-              </a:defRPr>
-            </a:pPr>
-            <a:r>
-              <a:t>Cardano Risk Analyst  /  x402  /  Sokosumi  /  Masumi</a:t>
+                <a:latin typeface="JetBrains Mono"/>
+              </a:defRPr>
+            </a:pPr>
+            <a:r>
+              <a:t>Cardano Risk Desk  /  x402  /  Sokosumi  /  Masumi</a:t>
             </a:r>
           </a:p>
         </p:txBody>
@@ -6854,8 +6372,8 @@
         </p:nvSpPr>
         <p:spPr>
           <a:xfrm>
-            <a:off x="640080" y="411480"/>
-            <a:ext cx="10698480" cy="594360"/>
+            <a:off x="640080" y="365760"/>
+            <a:ext cx="10698480" cy="256032"/>
           </a:xfrm>
           <a:prstGeom prst="rect">
             <a:avLst/>
@@ -6869,7 +6387,43 @@
           <a:lstStyle/>
           <a:p>
             <a:pPr algn="l">
-              <a:defRPr sz="3400" b="1">
+              <a:defRPr sz="1000" b="0">
+                <a:solidFill>
+                  <a:srgbClr val="5A6472"/>
+                </a:solidFill>
+                <a:latin typeface="JetBrains Mono"/>
+              </a:defRPr>
+            </a:pPr>
+            <a:r>
+              <a:t>ONE-LINE INTEGRATION</a:t>
+            </a:r>
+          </a:p>
+        </p:txBody>
+      </p:sp>
+      <p:sp>
+        <p:nvSpPr>
+          <p:cNvPr id="3" name="TextBox 2"/>
+          <p:cNvSpPr txBox="1"/>
+          <p:nvPr/>
+        </p:nvSpPr>
+        <p:spPr>
+          <a:xfrm>
+            <a:off x="640080" y="749808"/>
+            <a:ext cx="10698480" cy="658368"/>
+          </a:xfrm>
+          <a:prstGeom prst="rect">
+            <a:avLst/>
+          </a:prstGeom>
+          <a:noFill/>
+        </p:spPr>
+        <p:txBody>
+          <a:bodyPr wrap="square">
+            <a:spAutoFit/>
+          </a:bodyPr>
+          <a:lstStyle/>
+          <a:p>
+            <a:pPr algn="l">
+              <a:defRPr sz="3100" b="1">
                 <a:solidFill>
                   <a:srgbClr val="1F242E"/>
                 </a:solidFill>
@@ -6877,20 +6431,20 @@
               </a:defRPr>
             </a:pPr>
             <a:r>
-              <a:t>Mainnet evidence: SNEK and MINt</a:t>
-            </a:r>
-          </a:p>
-        </p:txBody>
-      </p:sp>
-      <p:sp>
-        <p:nvSpPr>
-          <p:cNvPr id="3" name="Rectangle 2"/>
+              <a:t>Put the Risk Desk where the wallet would have signed.</a:t>
+            </a:r>
+          </a:p>
+        </p:txBody>
+      </p:sp>
+      <p:sp>
+        <p:nvSpPr>
+          <p:cNvPr id="4" name="Rectangle 3"/>
           <p:cNvSpPr/>
           <p:nvPr/>
         </p:nvSpPr>
         <p:spPr>
           <a:xfrm>
-            <a:off x="640080" y="1115568"/>
+            <a:off x="640080" y="1536192"/>
             <a:ext cx="822960" cy="64008"/>
           </a:xfrm>
           <a:prstGeom prst="rect">
@@ -6927,7 +6481,7 @@
       </p:sp>
       <p:sp>
         <p:nvSpPr>
-          <p:cNvPr id="4" name="TextBox 3"/>
+          <p:cNvPr id="5" name="TextBox 4"/>
           <p:cNvSpPr txBox="1"/>
           <p:nvPr/>
         </p:nvSpPr>
@@ -6952,119 +6506,67 @@
                 <a:solidFill>
                   <a:srgbClr val="5A6472"/>
                 </a:solidFill>
-                <a:latin typeface="Courier New"/>
-              </a:defRPr>
-            </a:pPr>
-            <a:r>
-              <a:t>08 / 11</a:t>
-            </a:r>
-          </a:p>
-        </p:txBody>
-      </p:sp>
-      <p:sp>
-        <p:nvSpPr>
-          <p:cNvPr id="5" name="Rectangle 4"/>
+                <a:latin typeface="JetBrains Mono"/>
+              </a:defRPr>
+            </a:pPr>
+            <a:r>
+              <a:t>08 / 10</a:t>
+            </a:r>
+          </a:p>
+        </p:txBody>
+      </p:sp>
+      <p:sp>
+        <p:nvSpPr>
+          <p:cNvPr id="6" name="TextBox 5"/>
+          <p:cNvSpPr txBox="1"/>
+          <p:nvPr/>
+        </p:nvSpPr>
+        <p:spPr>
+          <a:xfrm>
+            <a:off x="640080" y="1783080"/>
+            <a:ext cx="10698480" cy="457200"/>
+          </a:xfrm>
+          <a:prstGeom prst="rect">
+            <a:avLst/>
+          </a:prstGeom>
+          <a:noFill/>
+        </p:spPr>
+        <p:txBody>
+          <a:bodyPr wrap="square">
+            <a:spAutoFit/>
+          </a:bodyPr>
+          <a:lstStyle/>
+          <a:p>
+            <a:pPr algn="l">
+              <a:defRPr sz="1900" b="0">
+                <a:solidFill>
+                  <a:srgbClr val="1F242E"/>
+                </a:solidFill>
+                <a:latin typeface="Inter"/>
+              </a:defRPr>
+            </a:pPr>
+            <a:r>
+              <a:t>The agent keeps its existing seller call. Add one paid check before the final payment.</a:t>
+            </a:r>
+          </a:p>
+        </p:txBody>
+      </p:sp>
+      <p:sp>
+        <p:nvSpPr>
+          <p:cNvPr id="7" name="Rectangle 6"/>
           <p:cNvSpPr/>
           <p:nvPr/>
         </p:nvSpPr>
         <p:spPr>
           <a:xfrm>
-            <a:off x="640080" y="1874519"/>
-            <a:ext cx="5166360" cy="3108960"/>
+            <a:off x="640080" y="2514600"/>
+            <a:ext cx="10881360" cy="1508760"/>
           </a:xfrm>
           <a:prstGeom prst="rect">
             <a:avLst/>
           </a:prstGeom>
           <a:solidFill>
-            <a:srgbClr val="F8F9FB"/>
-          </a:solidFill>
-          <a:ln w="15240">
-            <a:solidFill>
-              <a:srgbClr val="4678E8"/>
-            </a:solidFill>
-          </a:ln>
-        </p:spPr>
-        <p:style>
-          <a:lnRef idx="1">
-            <a:schemeClr val="accent1"/>
-          </a:lnRef>
-          <a:fillRef idx="3">
-            <a:schemeClr val="accent1"/>
-          </a:fillRef>
-          <a:effectRef idx="2">
-            <a:schemeClr val="accent1"/>
-          </a:effectRef>
-          <a:fontRef idx="minor">
-            <a:schemeClr val="lt1"/>
-          </a:fontRef>
-        </p:style>
-        <p:txBody>
-          <a:bodyPr rtlCol="0" anchor="ctr" wrap="square"/>
-          <a:lstStyle/>
-          <a:p>
-            <a:pPr algn="ctr">
-              <a:defRPr sz="1700" b="1">
-                <a:solidFill>
-                  <a:srgbClr val="4678E8"/>
-                </a:solidFill>
-                <a:latin typeface="Space Grotesk"/>
-              </a:defRPr>
-            </a:pPr>
-            <a:r>
-              <a:t>SNEK  /  INTERACT</a:t>
-            </a:r>
-          </a:p>
-          <a:p>
-            <a:pPr>
-              <a:defRPr sz="1300">
-                <a:solidFill>
-                  <a:srgbClr val="1F242E"/>
-                </a:solidFill>
-                <a:latin typeface="Arial"/>
-              </a:defRPr>
-            </a:pPr>
-            <a:r>
-              <a:t>Native policy is timelocked</a:t>
-            </a:r>
-            <a:br/>
-            <a:r>
-              <a:t>Mint policy: closed</a:t>
-            </a:r>
-            <a:br/>
-            <a:r>
-              <a:t>999 sampled holders</a:t>
-            </a:r>
-            <a:br/>
-            <a:r>
-              <a:t>Top 1: 4.0821102137%</a:t>
-            </a:r>
-            <a:br/>
-            <a:r>
-              <a:t>Top 10: 4.3279131478%</a:t>
-            </a:r>
-            <a:br/>
-            <a:r>
-              <a:t>Report: engine/reports/SNEK.json</a:t>
-            </a:r>
-          </a:p>
-        </p:txBody>
-      </p:sp>
-      <p:sp>
-        <p:nvSpPr>
-          <p:cNvPr id="6" name="Rectangle 5"/>
-          <p:cNvSpPr/>
-          <p:nvPr/>
-        </p:nvSpPr>
-        <p:spPr>
-          <a:xfrm>
-            <a:off x="6172200" y="1874519"/>
-            <a:ext cx="5349240" cy="3108960"/>
-          </a:xfrm>
-          <a:prstGeom prst="rect">
-            <a:avLst/>
-          </a:prstGeom>
-          <a:solidFill>
-            <a:srgbClr val="F8F9FB"/>
+            <a:srgbClr val="222731"/>
           </a:solidFill>
           <a:ln w="15240">
             <a:solidFill>
@@ -7093,56 +6595,44 @@
             <a:pPr algn="ctr">
               <a:defRPr sz="1700" b="1">
                 <a:solidFill>
-                  <a:srgbClr val="1F242E"/>
+                  <a:srgbClr val="F8F9FB"/>
                 </a:solidFill>
                 <a:latin typeface="Space Grotesk"/>
               </a:defRPr>
             </a:pPr>
             <a:r>
-              <a:t>MINt  /  DO NOT INTERACT</a:t>
+              <a:t>curl</a:t>
             </a:r>
           </a:p>
           <a:p>
             <a:pPr>
               <a:defRPr sz="1300">
                 <a:solidFill>
-                  <a:srgbClr val="1F242E"/>
-                </a:solidFill>
-                <a:latin typeface="Arial"/>
-              </a:defRPr>
-            </a:pPr>
-            <a:r>
-              <a:t>Native policy remains open</a:t>
+                  <a:srgbClr val="F8F9FB"/>
+                </a:solidFill>
+                <a:latin typeface="JetBrains Mono"/>
+              </a:defRPr>
+            </a:pPr>
+            <a:r>
+              <a:t>curl -i https://cardano-risk-coworker.vercel.app/api/x402/risk-check \\</a:t>
             </a:r>
             <a:br/>
             <a:r>
-              <a:t>1 required signer</a:t>
-            </a:r>
-            <a:br/>
-            <a:r>
-              <a:t>Minswap liquidity: 1766.66 ADA</a:t>
-            </a:r>
-            <a:br/>
-            <a:r>
-              <a:t>Findings: mint-open, liquidity</a:t>
-            </a:r>
-            <a:br/>
-            <a:r>
-              <a:t>Report: engine/reports/MINt.json</a:t>
-            </a:r>
-          </a:p>
-        </p:txBody>
-      </p:sp>
-      <p:sp>
-        <p:nvSpPr>
-          <p:cNvPr id="7" name="TextBox 6"/>
+              <a:t>  -H 'x-payment: &lt;signed-cardano-payment&gt;'</a:t>
+            </a:r>
+          </a:p>
+        </p:txBody>
+      </p:sp>
+      <p:sp>
+        <p:nvSpPr>
+          <p:cNvPr id="8" name="TextBox 7"/>
           <p:cNvSpPr txBox="1"/>
           <p:nvPr/>
         </p:nvSpPr>
         <p:spPr>
           <a:xfrm>
-            <a:off x="640080" y="6355080"/>
-            <a:ext cx="8686800" cy="228600"/>
+            <a:off x="640080" y="4617720"/>
+            <a:ext cx="10698480" cy="411480"/>
           </a:xfrm>
           <a:prstGeom prst="rect">
             <a:avLst/>
@@ -7155,16 +6645,52 @@
           </a:bodyPr>
           <a:lstStyle/>
           <a:p>
+            <a:pPr algn="ctr">
+              <a:defRPr sz="1800" b="1">
+                <a:solidFill>
+                  <a:srgbClr val="1F242E"/>
+                </a:solidFill>
+                <a:latin typeface="Inter"/>
+              </a:defRPr>
+            </a:pPr>
+            <a:r>
+              <a:t>402  →  pay the Risk Desk  →  read the assessment  →  continue or refuse</a:t>
+            </a:r>
+          </a:p>
+        </p:txBody>
+      </p:sp>
+      <p:sp>
+        <p:nvSpPr>
+          <p:cNvPr id="9" name="TextBox 8"/>
+          <p:cNvSpPr txBox="1"/>
+          <p:nvPr/>
+        </p:nvSpPr>
+        <p:spPr>
+          <a:xfrm>
+            <a:off x="640080" y="6355080"/>
+            <a:ext cx="8686800" cy="228600"/>
+          </a:xfrm>
+          <a:prstGeom prst="rect">
+            <a:avLst/>
+          </a:prstGeom>
+          <a:noFill/>
+        </p:spPr>
+        <p:txBody>
+          <a:bodyPr wrap="square">
+            <a:spAutoFit/>
+          </a:bodyPr>
+          <a:lstStyle/>
+          <a:p>
             <a:pPr algn="l">
               <a:defRPr sz="1000" b="0">
                 <a:solidFill>
                   <a:srgbClr val="5A6472"/>
                 </a:solidFill>
-                <a:latin typeface="Courier New"/>
-              </a:defRPr>
-            </a:pPr>
-            <a:r>
-              <a:t>Cardano Risk Analyst  /  x402  /  Sokosumi  /  Masumi</a:t>
+                <a:latin typeface="JetBrains Mono"/>
+              </a:defRPr>
+            </a:pPr>
+            <a:r>
+              <a:t>Cardano Risk Desk  /  x402  /  Sokosumi  /  Masumi</a:t>
             </a:r>
           </a:p>
         </p:txBody>
@@ -7203,8 +6729,8 @@
         </p:nvSpPr>
         <p:spPr>
           <a:xfrm>
-            <a:off x="640080" y="411480"/>
-            <a:ext cx="10698480" cy="594360"/>
+            <a:off x="640080" y="365760"/>
+            <a:ext cx="10698480" cy="256032"/>
           </a:xfrm>
           <a:prstGeom prst="rect">
             <a:avLst/>
@@ -7218,7 +6744,43 @@
           <a:lstStyle/>
           <a:p>
             <a:pPr algn="l">
-              <a:defRPr sz="3400" b="1">
+              <a:defRPr sz="1000" b="0">
+                <a:solidFill>
+                  <a:srgbClr val="5A6472"/>
+                </a:solidFill>
+                <a:latin typeface="JetBrains Mono"/>
+              </a:defRPr>
+            </a:pPr>
+            <a:r>
+              <a:t>WHY CARDANO + MASUMI</a:t>
+            </a:r>
+          </a:p>
+        </p:txBody>
+      </p:sp>
+      <p:sp>
+        <p:nvSpPr>
+          <p:cNvPr id="3" name="TextBox 2"/>
+          <p:cNvSpPr txBox="1"/>
+          <p:nvPr/>
+        </p:nvSpPr>
+        <p:spPr>
+          <a:xfrm>
+            <a:off x="640080" y="749808"/>
+            <a:ext cx="10698480" cy="658368"/>
+          </a:xfrm>
+          <a:prstGeom prst="rect">
+            <a:avLst/>
+          </a:prstGeom>
+          <a:noFill/>
+        </p:spPr>
+        <p:txBody>
+          <a:bodyPr wrap="square">
+            <a:spAutoFit/>
+          </a:bodyPr>
+          <a:lstStyle/>
+          <a:p>
+            <a:pPr algn="l">
+              <a:defRPr sz="3100" b="1">
                 <a:solidFill>
                   <a:srgbClr val="1F242E"/>
                 </a:solidFill>
@@ -7226,20 +6788,20 @@
               </a:defRPr>
             </a:pPr>
             <a:r>
-              <a:t>The pool report makes exit evidence concrete</a:t>
-            </a:r>
-          </a:p>
-        </p:txBody>
-      </p:sp>
-      <p:sp>
-        <p:nvSpPr>
-          <p:cNvPr id="3" name="Rectangle 2"/>
+              <a:t>Cardano supplies the evidence. Masumi supplies the accountable work.</a:t>
+            </a:r>
+          </a:p>
+        </p:txBody>
+      </p:sp>
+      <p:sp>
+        <p:nvSpPr>
+          <p:cNvPr id="4" name="Rectangle 3"/>
           <p:cNvSpPr/>
           <p:nvPr/>
         </p:nvSpPr>
         <p:spPr>
           <a:xfrm>
-            <a:off x="640080" y="1115568"/>
+            <a:off x="640080" y="1536192"/>
             <a:ext cx="822960" cy="64008"/>
           </a:xfrm>
           <a:prstGeom prst="rect">
@@ -7276,7 +6838,7 @@
       </p:sp>
       <p:sp>
         <p:nvSpPr>
-          <p:cNvPr id="4" name="TextBox 3"/>
+          <p:cNvPr id="5" name="TextBox 4"/>
           <p:cNvSpPr txBox="1"/>
           <p:nvPr/>
         </p:nvSpPr>
@@ -7301,47 +6863,11 @@
                 <a:solidFill>
                   <a:srgbClr val="5A6472"/>
                 </a:solidFill>
-                <a:latin typeface="Courier New"/>
-              </a:defRPr>
-            </a:pPr>
-            <a:r>
-              <a:t>09 / 11</a:t>
-            </a:r>
-          </a:p>
-        </p:txBody>
-      </p:sp>
-      <p:sp>
-        <p:nvSpPr>
-          <p:cNvPr id="5" name="TextBox 4"/>
-          <p:cNvSpPr txBox="1"/>
-          <p:nvPr/>
-        </p:nvSpPr>
-        <p:spPr>
-          <a:xfrm>
-            <a:off x="640080" y="1508760"/>
-            <a:ext cx="10698480" cy="502920"/>
-          </a:xfrm>
-          <a:prstGeom prst="rect">
-            <a:avLst/>
-          </a:prstGeom>
-          <a:noFill/>
-        </p:spPr>
-        <p:txBody>
-          <a:bodyPr wrap="square">
-            <a:spAutoFit/>
-          </a:bodyPr>
-          <a:lstStyle/>
-          <a:p>
-            <a:pPr algn="l">
-              <a:defRPr sz="2300" b="0">
-                <a:solidFill>
-                  <a:srgbClr val="1F242E"/>
-                </a:solidFill>
-                <a:latin typeface="Arial"/>
-              </a:defRPr>
-            </a:pPr>
-            <a:r>
-              <a:t>Minswap V2 is identified as a known Plutus protocol script.</a:t>
+                <a:latin typeface="JetBrains Mono"/>
+              </a:defRPr>
+            </a:pPr>
+            <a:r>
+              <a:t>09 / 10</a:t>
             </a:r>
           </a:p>
         </p:txBody>
@@ -7354,8 +6880,8 @@
         </p:nvSpPr>
         <p:spPr>
           <a:xfrm>
-            <a:off x="640080" y="2240280"/>
-            <a:ext cx="5212080" cy="2560320"/>
+            <a:off x="640080" y="2057400"/>
+            <a:ext cx="5212080" cy="2743200"/>
           </a:xfrm>
           <a:prstGeom prst="rect">
             <a:avLst/>
@@ -7396,7 +6922,7 @@
               </a:defRPr>
             </a:pPr>
             <a:r>
-              <a:t>INTERACT</a:t>
+              <a:t>Cardano</a:t>
             </a:r>
           </a:p>
           <a:p>
@@ -7405,27 +6931,21 @@
                 <a:solidFill>
                   <a:srgbClr val="1F242E"/>
                 </a:solidFill>
-                <a:latin typeface="Arial"/>
-              </a:defRPr>
-            </a:pPr>
-            <a:r>
-              <a:t>Script type: plutusV2</a:t>
+                <a:latin typeface="Inter"/>
+              </a:defRPr>
+            </a:pPr>
+            <a:r>
+              <a:t>Native asset policies expose mint authority.</a:t>
             </a:r>
             <a:br/>
-            <a:r>
-              <a:t>Script size: 3965 bytes</a:t>
-            </a:r>
             <a:br/>
             <a:r>
-              <a:t>TVL: 23409267.450065 ADA</a:t>
+              <a:t>Addresses and scripts are inspectable on chain.</a:t>
             </a:r>
             <a:br/>
-            <a:r>
-              <a:t>Recent tx count: 1000</a:t>
-            </a:r>
             <a:br/>
             <a:r>
-              <a:t>Known protocol: Minswap V2 pool</a:t>
+              <a:t>Koios turns those facts into cited evidence.</a:t>
             </a:r>
           </a:p>
         </p:txBody>
@@ -7438,14 +6958,14 @@
         </p:nvSpPr>
         <p:spPr>
           <a:xfrm>
-            <a:off x="6217920" y="2240280"/>
-            <a:ext cx="5303520" cy="2560320"/>
+            <a:off x="6217920" y="2057400"/>
+            <a:ext cx="5303520" cy="2743200"/>
           </a:xfrm>
           <a:prstGeom prst="rect">
             <a:avLst/>
           </a:prstGeom>
           <a:solidFill>
-            <a:srgbClr val="222731"/>
+            <a:srgbClr val="F8F9FB"/>
           </a:solidFill>
           <a:ln w="15240">
             <a:solidFill>
@@ -7474,38 +6994,36 @@
             <a:pPr algn="ctr">
               <a:defRPr sz="1700" b="1">
                 <a:solidFill>
-                  <a:srgbClr val="F8F9FB"/>
+                  <a:srgbClr val="1F242E"/>
                 </a:solidFill>
                 <a:latin typeface="Space Grotesk"/>
               </a:defRPr>
             </a:pPr>
             <a:r>
-              <a:t>Source calls</a:t>
+              <a:t>Masumi</a:t>
             </a:r>
           </a:p>
           <a:p>
             <a:pPr>
               <a:defRPr sz="1300">
                 <a:solidFill>
-                  <a:srgbClr val="F8F9FB"/>
-                </a:solidFill>
-                <a:latin typeface="Courier New"/>
-              </a:defRPr>
-            </a:pPr>
-            <a:r>
-              <a:t>script_info_ea07b733...</a:t>
+                  <a:srgbClr val="1F242E"/>
+                </a:solidFill>
+                <a:latin typeface="Inter"/>
+              </a:defRPr>
+            </a:pPr>
+            <a:r>
+              <a:t>The Coworker is discoverable through Sokosumi.</a:t>
             </a:r>
             <a:br/>
-            <a:r>
-              <a:t>address_utxos_addr1z84...</a:t>
-            </a:r>
             <a:br/>
             <a:r>
-              <a:t>address_txs_addr1z84...</a:t>
+              <a:t>A task makes the decision accountable.</a:t>
             </a:r>
             <a:br/>
-            <a:r>
-              <a:t>Report: engine/reports/POOL-MINSWAP.json</a:t>
+            <a:br/>
+            <a:r>
+              <a:t>Payment turns the check into a service an agent can hire.</a:t>
             </a:r>
           </a:p>
         </p:txBody>
@@ -7537,11 +7055,11 @@
                 <a:solidFill>
                   <a:srgbClr val="5A6472"/>
                 </a:solidFill>
-                <a:latin typeface="Courier New"/>
-              </a:defRPr>
-            </a:pPr>
-            <a:r>
-              <a:t>Cardano Risk Analyst  /  x402  /  Sokosumi  /  Masumi</a:t>
+                <a:latin typeface="JetBrains Mono"/>
+              </a:defRPr>
+            </a:pPr>
+            <a:r>
+              <a:t>Cardano Risk Desk  /  x402  /  Sokosumi  /  Masumi</a:t>
             </a:r>
           </a:p>
         </p:txBody>

</xml_diff>